<commit_message>
changed from protocol to protocol & architecture style for gRPC, REST
</commit_message>
<xml_diff>
--- a/results/gRPC, REST, Protobuf, JSON_withConcurrency.pptx
+++ b/results/gRPC, REST, Protobuf, JSON_withConcurrency.pptx
@@ -5,7 +5,7 @@
     <p:sldMasterId id="2147483648" r:id="rId1"/>
   </p:sldMasterIdLst>
   <p:notesMasterIdLst>
-    <p:notesMasterId r:id="rId27"/>
+    <p:notesMasterId r:id="rId30"/>
   </p:notesMasterIdLst>
   <p:sldIdLst>
     <p:sldId id="256" r:id="rId2"/>
@@ -19,20 +19,23 @@
     <p:sldId id="259" r:id="rId10"/>
     <p:sldId id="260" r:id="rId11"/>
     <p:sldId id="266" r:id="rId12"/>
-    <p:sldId id="269" r:id="rId13"/>
-    <p:sldId id="262" r:id="rId14"/>
-    <p:sldId id="276" r:id="rId15"/>
-    <p:sldId id="263" r:id="rId16"/>
-    <p:sldId id="264" r:id="rId17"/>
-    <p:sldId id="265" r:id="rId18"/>
-    <p:sldId id="268" r:id="rId19"/>
-    <p:sldId id="267" r:id="rId20"/>
-    <p:sldId id="277" r:id="rId21"/>
-    <p:sldId id="278" r:id="rId22"/>
-    <p:sldId id="279" r:id="rId23"/>
-    <p:sldId id="280" r:id="rId24"/>
-    <p:sldId id="281" r:id="rId25"/>
-    <p:sldId id="283" r:id="rId26"/>
+    <p:sldId id="284" r:id="rId13"/>
+    <p:sldId id="269" r:id="rId14"/>
+    <p:sldId id="262" r:id="rId15"/>
+    <p:sldId id="276" r:id="rId16"/>
+    <p:sldId id="263" r:id="rId17"/>
+    <p:sldId id="264" r:id="rId18"/>
+    <p:sldId id="265" r:id="rId19"/>
+    <p:sldId id="268" r:id="rId20"/>
+    <p:sldId id="285" r:id="rId21"/>
+    <p:sldId id="267" r:id="rId22"/>
+    <p:sldId id="277" r:id="rId23"/>
+    <p:sldId id="278" r:id="rId24"/>
+    <p:sldId id="279" r:id="rId25"/>
+    <p:sldId id="280" r:id="rId26"/>
+    <p:sldId id="281" r:id="rId27"/>
+    <p:sldId id="286" r:id="rId28"/>
+    <p:sldId id="283" r:id="rId29"/>
   </p:sldIdLst>
   <p:sldSz cx="12192000" cy="6858000"/>
   <p:notesSz cx="6858000" cy="9144000"/>
@@ -221,7 +224,7 @@
           <a:p>
             <a:fld id="{2FA8EDEC-DE15-40C5-A4EB-DDAC704C4504}" type="datetimeFigureOut">
               <a:rPr lang="en-US" smtClean="0"/>
-              <a:t>7/17/2025</a:t>
+              <a:t>7/20/2025</a:t>
             </a:fld>
             <a:endParaRPr lang="en-US"/>
           </a:p>
@@ -746,7 +749,7 @@
           <a:p>
             <a:fld id="{2DA65C6F-9ADB-48CC-86E4-D074ED41C5D5}" type="slidenum">
               <a:rPr lang="en-US" smtClean="0"/>
-              <a:t>16</a:t>
+              <a:t>17</a:t>
             </a:fld>
             <a:endParaRPr lang="en-US"/>
           </a:p>
@@ -830,7 +833,7 @@
           <a:p>
             <a:fld id="{2DA65C6F-9ADB-48CC-86E4-D074ED41C5D5}" type="slidenum">
               <a:rPr lang="en-US" smtClean="0"/>
-              <a:t>17</a:t>
+              <a:t>18</a:t>
             </a:fld>
             <a:endParaRPr lang="en-US"/>
           </a:p>
@@ -914,7 +917,7 @@
           <a:p>
             <a:fld id="{2DA65C6F-9ADB-48CC-86E4-D074ED41C5D5}" type="slidenum">
               <a:rPr lang="en-US" smtClean="0"/>
-              <a:t>18</a:t>
+              <a:t>19</a:t>
             </a:fld>
             <a:endParaRPr lang="en-US"/>
           </a:p>
@@ -934,6 +937,114 @@
 </file>
 
 <file path=ppt/notesSlides/notesSlide13.xml><?xml version="1.0" encoding="utf-8"?>
+<p:notes xmlns:a="http://schemas.openxmlformats.org/drawingml/2006/main" xmlns:r="http://schemas.openxmlformats.org/officeDocument/2006/relationships" xmlns:p="http://schemas.openxmlformats.org/presentationml/2006/main">
+  <p:cSld>
+    <p:spTree>
+      <p:nvGrpSpPr>
+        <p:cNvPr id="1" name="">
+          <a:extLst>
+            <a:ext uri="{FF2B5EF4-FFF2-40B4-BE49-F238E27FC236}">
+              <a16:creationId xmlns:a16="http://schemas.microsoft.com/office/drawing/2014/main" id="{81A859B9-7241-5F44-C15A-82E2FD681B56}"/>
+            </a:ext>
+          </a:extLst>
+        </p:cNvPr>
+        <p:cNvGrpSpPr/>
+        <p:nvPr/>
+      </p:nvGrpSpPr>
+      <p:grpSpPr>
+        <a:xfrm>
+          <a:off x="0" y="0"/>
+          <a:ext cx="0" cy="0"/>
+          <a:chOff x="0" y="0"/>
+          <a:chExt cx="0" cy="0"/>
+        </a:xfrm>
+      </p:grpSpPr>
+      <p:sp>
+        <p:nvSpPr>
+          <p:cNvPr id="2" name="Slide Image Placeholder 1">
+            <a:extLst>
+              <a:ext uri="{FF2B5EF4-FFF2-40B4-BE49-F238E27FC236}">
+                <a16:creationId xmlns:a16="http://schemas.microsoft.com/office/drawing/2014/main" id="{42F85B5C-E941-2915-B967-FFD71B3C62F7}"/>
+              </a:ext>
+            </a:extLst>
+          </p:cNvPr>
+          <p:cNvSpPr>
+            <a:spLocks noGrp="1" noRot="1" noChangeAspect="1"/>
+          </p:cNvSpPr>
+          <p:nvPr>
+            <p:ph type="sldImg"/>
+          </p:nvPr>
+        </p:nvSpPr>
+        <p:spPr/>
+      </p:sp>
+      <p:sp>
+        <p:nvSpPr>
+          <p:cNvPr id="3" name="Notes Placeholder 2">
+            <a:extLst>
+              <a:ext uri="{FF2B5EF4-FFF2-40B4-BE49-F238E27FC236}">
+                <a16:creationId xmlns:a16="http://schemas.microsoft.com/office/drawing/2014/main" id="{783A5D4B-4ACE-3EFD-73B0-D4F1B6A53A68}"/>
+              </a:ext>
+            </a:extLst>
+          </p:cNvPr>
+          <p:cNvSpPr>
+            <a:spLocks noGrp="1"/>
+          </p:cNvSpPr>
+          <p:nvPr>
+            <p:ph type="body" idx="1"/>
+          </p:nvPr>
+        </p:nvSpPr>
+        <p:spPr/>
+        <p:txBody>
+          <a:bodyPr/>
+          <a:lstStyle/>
+          <a:p>
+            <a:endParaRPr lang="en-US" dirty="0"/>
+          </a:p>
+        </p:txBody>
+      </p:sp>
+      <p:sp>
+        <p:nvSpPr>
+          <p:cNvPr id="4" name="Slide Number Placeholder 3">
+            <a:extLst>
+              <a:ext uri="{FF2B5EF4-FFF2-40B4-BE49-F238E27FC236}">
+                <a16:creationId xmlns:a16="http://schemas.microsoft.com/office/drawing/2014/main" id="{7CF1A257-5170-7F57-17BF-4A533861C92E}"/>
+              </a:ext>
+            </a:extLst>
+          </p:cNvPr>
+          <p:cNvSpPr>
+            <a:spLocks noGrp="1"/>
+          </p:cNvSpPr>
+          <p:nvPr>
+            <p:ph type="sldNum" sz="quarter" idx="5"/>
+          </p:nvPr>
+        </p:nvSpPr>
+        <p:spPr/>
+        <p:txBody>
+          <a:bodyPr/>
+          <a:lstStyle/>
+          <a:p>
+            <a:fld id="{2DA65C6F-9ADB-48CC-86E4-D074ED41C5D5}" type="slidenum">
+              <a:rPr lang="en-US" smtClean="0"/>
+              <a:t>20</a:t>
+            </a:fld>
+            <a:endParaRPr lang="en-US"/>
+          </a:p>
+        </p:txBody>
+      </p:sp>
+    </p:spTree>
+    <p:extLst>
+      <p:ext uri="{BB962C8B-B14F-4D97-AF65-F5344CB8AC3E}">
+        <p14:creationId xmlns:p14="http://schemas.microsoft.com/office/powerpoint/2010/main" val="220910929"/>
+      </p:ext>
+    </p:extLst>
+  </p:cSld>
+  <p:clrMapOvr>
+    <a:masterClrMapping/>
+  </p:clrMapOvr>
+</p:notes>
+</file>
+
+<file path=ppt/notesSlides/notesSlide14.xml><?xml version="1.0" encoding="utf-8"?>
 <p:notes xmlns:a="http://schemas.openxmlformats.org/drawingml/2006/main" xmlns:r="http://schemas.openxmlformats.org/officeDocument/2006/relationships" xmlns:p="http://schemas.openxmlformats.org/presentationml/2006/main">
   <p:cSld>
     <p:spTree>
@@ -1083,7 +1194,7 @@
           <a:p>
             <a:fld id="{2DA65C6F-9ADB-48CC-86E4-D074ED41C5D5}" type="slidenum">
               <a:rPr lang="en-US" smtClean="0"/>
-              <a:t>21</a:t>
+              <a:t>23</a:t>
             </a:fld>
             <a:endParaRPr lang="en-US"/>
           </a:p>
@@ -1102,7 +1213,7 @@
 </p:notes>
 </file>
 
-<file path=ppt/notesSlides/notesSlide14.xml><?xml version="1.0" encoding="utf-8"?>
+<file path=ppt/notesSlides/notesSlide15.xml><?xml version="1.0" encoding="utf-8"?>
 <p:notes xmlns:a="http://schemas.openxmlformats.org/drawingml/2006/main" xmlns:r="http://schemas.openxmlformats.org/officeDocument/2006/relationships" xmlns:p="http://schemas.openxmlformats.org/presentationml/2006/main">
   <p:cSld>
     <p:spTree>
@@ -1191,7 +1302,7 @@
           <a:p>
             <a:fld id="{2DA65C6F-9ADB-48CC-86E4-D074ED41C5D5}" type="slidenum">
               <a:rPr lang="en-US" smtClean="0"/>
-              <a:t>22</a:t>
+              <a:t>24</a:t>
             </a:fld>
             <a:endParaRPr lang="en-US"/>
           </a:p>
@@ -1210,7 +1321,7 @@
 </p:notes>
 </file>
 
-<file path=ppt/notesSlides/notesSlide15.xml><?xml version="1.0" encoding="utf-8"?>
+<file path=ppt/notesSlides/notesSlide16.xml><?xml version="1.0" encoding="utf-8"?>
 <p:notes xmlns:a="http://schemas.openxmlformats.org/drawingml/2006/main" xmlns:r="http://schemas.openxmlformats.org/officeDocument/2006/relationships" xmlns:p="http://schemas.openxmlformats.org/presentationml/2006/main">
   <p:cSld>
     <p:spTree>
@@ -1299,7 +1410,7 @@
           <a:p>
             <a:fld id="{2DA65C6F-9ADB-48CC-86E4-D074ED41C5D5}" type="slidenum">
               <a:rPr lang="en-US" smtClean="0"/>
-              <a:t>23</a:t>
+              <a:t>25</a:t>
             </a:fld>
             <a:endParaRPr lang="en-US"/>
           </a:p>
@@ -1318,7 +1429,7 @@
 </p:notes>
 </file>
 
-<file path=ppt/notesSlides/notesSlide16.xml><?xml version="1.0" encoding="utf-8"?>
+<file path=ppt/notesSlides/notesSlide17.xml><?xml version="1.0" encoding="utf-8"?>
 <p:notes xmlns:a="http://schemas.openxmlformats.org/drawingml/2006/main" xmlns:r="http://schemas.openxmlformats.org/officeDocument/2006/relationships" xmlns:p="http://schemas.openxmlformats.org/presentationml/2006/main">
   <p:cSld>
     <p:spTree>
@@ -1407,7 +1518,7 @@
           <a:p>
             <a:fld id="{2DA65C6F-9ADB-48CC-86E4-D074ED41C5D5}" type="slidenum">
               <a:rPr lang="en-US" smtClean="0"/>
-              <a:t>24</a:t>
+              <a:t>26</a:t>
             </a:fld>
             <a:endParaRPr lang="en-US"/>
           </a:p>
@@ -1426,7 +1537,115 @@
 </p:notes>
 </file>
 
-<file path=ppt/notesSlides/notesSlide17.xml><?xml version="1.0" encoding="utf-8"?>
+<file path=ppt/notesSlides/notesSlide18.xml><?xml version="1.0" encoding="utf-8"?>
+<p:notes xmlns:a="http://schemas.openxmlformats.org/drawingml/2006/main" xmlns:r="http://schemas.openxmlformats.org/officeDocument/2006/relationships" xmlns:p="http://schemas.openxmlformats.org/presentationml/2006/main">
+  <p:cSld>
+    <p:spTree>
+      <p:nvGrpSpPr>
+        <p:cNvPr id="1" name="">
+          <a:extLst>
+            <a:ext uri="{FF2B5EF4-FFF2-40B4-BE49-F238E27FC236}">
+              <a16:creationId xmlns:a16="http://schemas.microsoft.com/office/drawing/2014/main" id="{BE2A32B3-C8B8-C804-DD5D-B5F82E6AB89D}"/>
+            </a:ext>
+          </a:extLst>
+        </p:cNvPr>
+        <p:cNvGrpSpPr/>
+        <p:nvPr/>
+      </p:nvGrpSpPr>
+      <p:grpSpPr>
+        <a:xfrm>
+          <a:off x="0" y="0"/>
+          <a:ext cx="0" cy="0"/>
+          <a:chOff x="0" y="0"/>
+          <a:chExt cx="0" cy="0"/>
+        </a:xfrm>
+      </p:grpSpPr>
+      <p:sp>
+        <p:nvSpPr>
+          <p:cNvPr id="2" name="Slide Image Placeholder 1">
+            <a:extLst>
+              <a:ext uri="{FF2B5EF4-FFF2-40B4-BE49-F238E27FC236}">
+                <a16:creationId xmlns:a16="http://schemas.microsoft.com/office/drawing/2014/main" id="{027BD361-8F92-D843-38D9-A964F231AE1D}"/>
+              </a:ext>
+            </a:extLst>
+          </p:cNvPr>
+          <p:cNvSpPr>
+            <a:spLocks noGrp="1" noRot="1" noChangeAspect="1"/>
+          </p:cNvSpPr>
+          <p:nvPr>
+            <p:ph type="sldImg"/>
+          </p:nvPr>
+        </p:nvSpPr>
+        <p:spPr/>
+      </p:sp>
+      <p:sp>
+        <p:nvSpPr>
+          <p:cNvPr id="3" name="Notes Placeholder 2">
+            <a:extLst>
+              <a:ext uri="{FF2B5EF4-FFF2-40B4-BE49-F238E27FC236}">
+                <a16:creationId xmlns:a16="http://schemas.microsoft.com/office/drawing/2014/main" id="{EBAC592B-A6A7-8EC1-8B90-2C30605A51F9}"/>
+              </a:ext>
+            </a:extLst>
+          </p:cNvPr>
+          <p:cNvSpPr>
+            <a:spLocks noGrp="1"/>
+          </p:cNvSpPr>
+          <p:nvPr>
+            <p:ph type="body" idx="1"/>
+          </p:nvPr>
+        </p:nvSpPr>
+        <p:spPr/>
+        <p:txBody>
+          <a:bodyPr/>
+          <a:lstStyle/>
+          <a:p>
+            <a:endParaRPr lang="en-US" dirty="0"/>
+          </a:p>
+        </p:txBody>
+      </p:sp>
+      <p:sp>
+        <p:nvSpPr>
+          <p:cNvPr id="4" name="Slide Number Placeholder 3">
+            <a:extLst>
+              <a:ext uri="{FF2B5EF4-FFF2-40B4-BE49-F238E27FC236}">
+                <a16:creationId xmlns:a16="http://schemas.microsoft.com/office/drawing/2014/main" id="{D71FADDD-98F0-53E6-2932-C9F83D5D739E}"/>
+              </a:ext>
+            </a:extLst>
+          </p:cNvPr>
+          <p:cNvSpPr>
+            <a:spLocks noGrp="1"/>
+          </p:cNvSpPr>
+          <p:nvPr>
+            <p:ph type="sldNum" sz="quarter" idx="5"/>
+          </p:nvPr>
+        </p:nvSpPr>
+        <p:spPr/>
+        <p:txBody>
+          <a:bodyPr/>
+          <a:lstStyle/>
+          <a:p>
+            <a:fld id="{2DA65C6F-9ADB-48CC-86E4-D074ED41C5D5}" type="slidenum">
+              <a:rPr lang="en-US" smtClean="0"/>
+              <a:t>27</a:t>
+            </a:fld>
+            <a:endParaRPr lang="en-US"/>
+          </a:p>
+        </p:txBody>
+      </p:sp>
+    </p:spTree>
+    <p:extLst>
+      <p:ext uri="{BB962C8B-B14F-4D97-AF65-F5344CB8AC3E}">
+        <p14:creationId xmlns:p14="http://schemas.microsoft.com/office/powerpoint/2010/main" val="4028634696"/>
+      </p:ext>
+    </p:extLst>
+  </p:cSld>
+  <p:clrMapOvr>
+    <a:masterClrMapping/>
+  </p:clrMapOvr>
+</p:notes>
+</file>
+
+<file path=ppt/notesSlides/notesSlide19.xml><?xml version="1.0" encoding="utf-8"?>
 <p:notes xmlns:a="http://schemas.openxmlformats.org/drawingml/2006/main" xmlns:r="http://schemas.openxmlformats.org/officeDocument/2006/relationships" xmlns:p="http://schemas.openxmlformats.org/presentationml/2006/main">
   <p:cSld>
     <p:spTree>
@@ -1717,7 +1936,7 @@
           <a:p>
             <a:fld id="{2DA65C6F-9ADB-48CC-86E4-D074ED41C5D5}" type="slidenum">
               <a:rPr lang="en-US" smtClean="0"/>
-              <a:t>25</a:t>
+              <a:t>28</a:t>
             </a:fld>
             <a:endParaRPr lang="en-US"/>
           </a:p>
@@ -2713,7 +2932,7 @@
           <a:p>
             <a:fld id="{2DA65C6F-9ADB-48CC-86E4-D074ED41C5D5}" type="slidenum">
               <a:rPr lang="en-US" smtClean="0"/>
-              <a:t>14</a:t>
+              <a:t>15</a:t>
             </a:fld>
             <a:endParaRPr lang="en-US"/>
           </a:p>
@@ -2882,7 +3101,7 @@
           <a:p>
             <a:fld id="{2DA65C6F-9ADB-48CC-86E4-D074ED41C5D5}" type="slidenum">
               <a:rPr lang="en-US" smtClean="0"/>
-              <a:t>15</a:t>
+              <a:t>16</a:t>
             </a:fld>
             <a:endParaRPr lang="en-US"/>
           </a:p>
@@ -3048,7 +3267,7 @@
           <a:p>
             <a:fld id="{698EF044-87D6-4710-9D25-D426445AAD07}" type="datetimeFigureOut">
               <a:rPr lang="en-US" smtClean="0"/>
-              <a:t>7/17/2025</a:t>
+              <a:t>7/20/2025</a:t>
             </a:fld>
             <a:endParaRPr lang="en-US"/>
           </a:p>
@@ -3246,7 +3465,7 @@
           <a:p>
             <a:fld id="{698EF044-87D6-4710-9D25-D426445AAD07}" type="datetimeFigureOut">
               <a:rPr lang="en-US" smtClean="0"/>
-              <a:t>7/17/2025</a:t>
+              <a:t>7/20/2025</a:t>
             </a:fld>
             <a:endParaRPr lang="en-US"/>
           </a:p>
@@ -3454,7 +3673,7 @@
           <a:p>
             <a:fld id="{698EF044-87D6-4710-9D25-D426445AAD07}" type="datetimeFigureOut">
               <a:rPr lang="en-US" smtClean="0"/>
-              <a:t>7/17/2025</a:t>
+              <a:t>7/20/2025</a:t>
             </a:fld>
             <a:endParaRPr lang="en-US"/>
           </a:p>
@@ -3652,7 +3871,7 @@
           <a:p>
             <a:fld id="{698EF044-87D6-4710-9D25-D426445AAD07}" type="datetimeFigureOut">
               <a:rPr lang="en-US" smtClean="0"/>
-              <a:t>7/17/2025</a:t>
+              <a:t>7/20/2025</a:t>
             </a:fld>
             <a:endParaRPr lang="en-US"/>
           </a:p>
@@ -3927,7 +4146,7 @@
           <a:p>
             <a:fld id="{698EF044-87D6-4710-9D25-D426445AAD07}" type="datetimeFigureOut">
               <a:rPr lang="en-US" smtClean="0"/>
-              <a:t>7/17/2025</a:t>
+              <a:t>7/20/2025</a:t>
             </a:fld>
             <a:endParaRPr lang="en-US"/>
           </a:p>
@@ -4192,7 +4411,7 @@
           <a:p>
             <a:fld id="{698EF044-87D6-4710-9D25-D426445AAD07}" type="datetimeFigureOut">
               <a:rPr lang="en-US" smtClean="0"/>
-              <a:t>7/17/2025</a:t>
+              <a:t>7/20/2025</a:t>
             </a:fld>
             <a:endParaRPr lang="en-US"/>
           </a:p>
@@ -4604,7 +4823,7 @@
           <a:p>
             <a:fld id="{698EF044-87D6-4710-9D25-D426445AAD07}" type="datetimeFigureOut">
               <a:rPr lang="en-US" smtClean="0"/>
-              <a:t>7/17/2025</a:t>
+              <a:t>7/20/2025</a:t>
             </a:fld>
             <a:endParaRPr lang="en-US"/>
           </a:p>
@@ -4745,7 +4964,7 @@
           <a:p>
             <a:fld id="{698EF044-87D6-4710-9D25-D426445AAD07}" type="datetimeFigureOut">
               <a:rPr lang="en-US" smtClean="0"/>
-              <a:t>7/17/2025</a:t>
+              <a:t>7/20/2025</a:t>
             </a:fld>
             <a:endParaRPr lang="en-US"/>
           </a:p>
@@ -4858,7 +5077,7 @@
           <a:p>
             <a:fld id="{698EF044-87D6-4710-9D25-D426445AAD07}" type="datetimeFigureOut">
               <a:rPr lang="en-US" smtClean="0"/>
-              <a:t>7/17/2025</a:t>
+              <a:t>7/20/2025</a:t>
             </a:fld>
             <a:endParaRPr lang="en-US"/>
           </a:p>
@@ -5169,7 +5388,7 @@
           <a:p>
             <a:fld id="{698EF044-87D6-4710-9D25-D426445AAD07}" type="datetimeFigureOut">
               <a:rPr lang="en-US" smtClean="0"/>
-              <a:t>7/17/2025</a:t>
+              <a:t>7/20/2025</a:t>
             </a:fld>
             <a:endParaRPr lang="en-US"/>
           </a:p>
@@ -5457,7 +5676,7 @@
           <a:p>
             <a:fld id="{698EF044-87D6-4710-9D25-D426445AAD07}" type="datetimeFigureOut">
               <a:rPr lang="en-US" smtClean="0"/>
-              <a:t>7/17/2025</a:t>
+              <a:t>7/20/2025</a:t>
             </a:fld>
             <a:endParaRPr lang="en-US"/>
           </a:p>
@@ -5698,7 +5917,7 @@
           <a:p>
             <a:fld id="{698EF044-87D6-4710-9D25-D426445AAD07}" type="datetimeFigureOut">
               <a:rPr lang="en-US" smtClean="0"/>
-              <a:t>7/17/2025</a:t>
+              <a:t>7/20/2025</a:t>
             </a:fld>
             <a:endParaRPr lang="en-US"/>
           </a:p>
@@ -8497,19 +8716,17 @@
       </p:sp>
       <p:pic>
         <p:nvPicPr>
-          <p:cNvPr id="13" name="Content Placeholder 12">
-            <a:extLst>
-              <a:ext uri="{FF2B5EF4-FFF2-40B4-BE49-F238E27FC236}">
-                <a16:creationId xmlns:a16="http://schemas.microsoft.com/office/drawing/2014/main" id="{A708D20E-59A6-986D-938C-E73300F71831}"/>
+          <p:cNvPr id="6" name="Picture 5">
+            <a:extLst>
+              <a:ext uri="{FF2B5EF4-FFF2-40B4-BE49-F238E27FC236}">
+                <a16:creationId xmlns:a16="http://schemas.microsoft.com/office/drawing/2014/main" id="{56D07F8A-5FDE-8C29-C539-6EA9AE87B519}"/>
               </a:ext>
             </a:extLst>
           </p:cNvPr>
           <p:cNvPicPr>
-            <a:picLocks noGrp="1" noChangeAspect="1"/>
+            <a:picLocks noChangeAspect="1"/>
           </p:cNvPicPr>
-          <p:nvPr>
-            <p:ph idx="1"/>
-          </p:nvPr>
+          <p:nvPr/>
         </p:nvPicPr>
         <p:blipFill>
           <a:blip r:embed="rId2"/>
@@ -8519,9 +8736,12 @@
         </p:blipFill>
         <p:spPr>
           <a:xfrm>
-            <a:off x="-12133" y="2358429"/>
-            <a:ext cx="12204132" cy="3714300"/>
+            <a:off x="-3" y="1827289"/>
+            <a:ext cx="12192000" cy="4782673"/>
           </a:xfrm>
+          <a:prstGeom prst="rect">
+            <a:avLst/>
+          </a:prstGeom>
         </p:spPr>
       </p:pic>
     </p:spTree>
@@ -8553,7 +8773,7 @@
         <p:cNvPr id="1" name="">
           <a:extLst>
             <a:ext uri="{FF2B5EF4-FFF2-40B4-BE49-F238E27FC236}">
-              <a16:creationId xmlns:a16="http://schemas.microsoft.com/office/drawing/2014/main" id="{1CE65C8C-8D12-9A18-4A9A-7F24FA03AA2E}"/>
+              <a16:creationId xmlns:a16="http://schemas.microsoft.com/office/drawing/2014/main" id="{8BFEC0C4-9E83-DFAF-7267-866BA64422D3}"/>
             </a:ext>
           </a:extLst>
         </p:cNvPr>
@@ -8573,7 +8793,7 @@
           <p:cNvPr id="10" name="Rectangle 9">
             <a:extLst>
               <a:ext uri="{FF2B5EF4-FFF2-40B4-BE49-F238E27FC236}">
-                <a16:creationId xmlns:a16="http://schemas.microsoft.com/office/drawing/2014/main" id="{B0388AAC-3ADC-4C99-101E-BBE738C1C8B1}"/>
+                <a16:creationId xmlns:a16="http://schemas.microsoft.com/office/drawing/2014/main" id="{651F8DB0-5BCA-6ECE-A73B-8DD9B64CC641}"/>
               </a:ext>
               <a:ext uri="{C183D7F6-B498-43B3-948B-1728B52AA6E4}">
                 <adec:decorative xmlns:adec="http://schemas.microsoft.com/office/drawing/2017/decorative" val="1"/>
@@ -8649,7 +8869,7 @@
           <p:cNvPr id="12" name="Rectangle 11">
             <a:extLst>
               <a:ext uri="{FF2B5EF4-FFF2-40B4-BE49-F238E27FC236}">
-                <a16:creationId xmlns:a16="http://schemas.microsoft.com/office/drawing/2014/main" id="{10F6C16A-4517-4FB5-22BE-F009DA915AF9}"/>
+                <a16:creationId xmlns:a16="http://schemas.microsoft.com/office/drawing/2014/main" id="{B4876409-4719-74DE-05D6-B014C7899F41}"/>
               </a:ext>
               <a:ext uri="{C183D7F6-B498-43B3-948B-1728B52AA6E4}">
                 <adec:decorative xmlns:adec="http://schemas.microsoft.com/office/drawing/2017/decorative" val="1"/>
@@ -8724,7 +8944,7 @@
           <p:cNvPr id="14" name="Rectangle 13">
             <a:extLst>
               <a:ext uri="{FF2B5EF4-FFF2-40B4-BE49-F238E27FC236}">
-                <a16:creationId xmlns:a16="http://schemas.microsoft.com/office/drawing/2014/main" id="{4ECDD89C-570F-36A9-BF7F-F81FF36C944F}"/>
+                <a16:creationId xmlns:a16="http://schemas.microsoft.com/office/drawing/2014/main" id="{0812B1A1-B789-1038-3BFF-E2D316B50B14}"/>
               </a:ext>
               <a:ext uri="{C183D7F6-B498-43B3-948B-1728B52AA6E4}">
                 <adec:decorative xmlns:adec="http://schemas.microsoft.com/office/drawing/2017/decorative" val="1"/>
@@ -8801,7 +9021,7 @@
           <p:cNvPr id="16" name="Rectangle 15">
             <a:extLst>
               <a:ext uri="{FF2B5EF4-FFF2-40B4-BE49-F238E27FC236}">
-                <a16:creationId xmlns:a16="http://schemas.microsoft.com/office/drawing/2014/main" id="{DED9CA6F-9682-A7A8-F411-6819E2556989}"/>
+                <a16:creationId xmlns:a16="http://schemas.microsoft.com/office/drawing/2014/main" id="{F698F281-1541-67AC-F4A7-6C68270634A0}"/>
               </a:ext>
               <a:ext uri="{C183D7F6-B498-43B3-948B-1728B52AA6E4}">
                 <adec:decorative xmlns:adec="http://schemas.microsoft.com/office/drawing/2017/decorative" val="1"/>
@@ -8876,6 +9096,424 @@
           <p:cNvPr id="2" name="Title 1">
             <a:extLst>
               <a:ext uri="{FF2B5EF4-FFF2-40B4-BE49-F238E27FC236}">
+                <a16:creationId xmlns:a16="http://schemas.microsoft.com/office/drawing/2014/main" id="{3AD28534-81BE-98B4-59B6-73B611E6272B}"/>
+              </a:ext>
+            </a:extLst>
+          </p:cNvPr>
+          <p:cNvSpPr>
+            <a:spLocks noGrp="1"/>
+          </p:cNvSpPr>
+          <p:nvPr>
+            <p:ph type="title"/>
+          </p:nvPr>
+        </p:nvSpPr>
+        <p:spPr>
+          <a:xfrm>
+            <a:off x="699713" y="248038"/>
+            <a:ext cx="7063721" cy="1159200"/>
+          </a:xfrm>
+        </p:spPr>
+        <p:txBody>
+          <a:bodyPr vert="horz" lIns="91440" tIns="45720" rIns="91440" bIns="45720" rtlCol="0" anchor="ctr">
+            <a:normAutofit/>
+          </a:bodyPr>
+          <a:lstStyle/>
+          <a:p>
+            <a:r>
+              <a:rPr lang="en-US" sz="4000" kern="1200">
+                <a:solidFill>
+                  <a:srgbClr val="FFFFFF"/>
+                </a:solidFill>
+                <a:latin typeface="+mj-lt"/>
+                <a:ea typeface="+mj-ea"/>
+                <a:cs typeface="+mj-cs"/>
+              </a:rPr>
+              <a:t>Overall View</a:t>
+            </a:r>
+          </a:p>
+        </p:txBody>
+      </p:sp>
+      <p:pic>
+        <p:nvPicPr>
+          <p:cNvPr id="13" name="Content Placeholder 12">
+            <a:extLst>
+              <a:ext uri="{FF2B5EF4-FFF2-40B4-BE49-F238E27FC236}">
+                <a16:creationId xmlns:a16="http://schemas.microsoft.com/office/drawing/2014/main" id="{42392802-02EB-ED20-2037-53DBA9B6C22C}"/>
+              </a:ext>
+            </a:extLst>
+          </p:cNvPr>
+          <p:cNvPicPr>
+            <a:picLocks noGrp="1" noChangeAspect="1"/>
+          </p:cNvPicPr>
+          <p:nvPr>
+            <p:ph idx="1"/>
+          </p:nvPr>
+        </p:nvPicPr>
+        <p:blipFill>
+          <a:blip r:embed="rId2"/>
+          <a:stretch>
+            <a:fillRect/>
+          </a:stretch>
+        </p:blipFill>
+        <p:spPr>
+          <a:xfrm>
+            <a:off x="-12133" y="2358429"/>
+            <a:ext cx="12204132" cy="3714300"/>
+          </a:xfrm>
+        </p:spPr>
+      </p:pic>
+    </p:spTree>
+    <p:extLst>
+      <p:ext uri="{BB962C8B-B14F-4D97-AF65-F5344CB8AC3E}">
+        <p14:creationId xmlns:p14="http://schemas.microsoft.com/office/powerpoint/2010/main" val="2935551873"/>
+      </p:ext>
+    </p:extLst>
+  </p:cSld>
+  <p:clrMapOvr>
+    <a:masterClrMapping/>
+  </p:clrMapOvr>
+</p:sld>
+</file>
+
+<file path=ppt/slides/slide13.xml><?xml version="1.0" encoding="utf-8"?>
+<p:sld xmlns:a="http://schemas.openxmlformats.org/drawingml/2006/main" xmlns:r="http://schemas.openxmlformats.org/officeDocument/2006/relationships" xmlns:p="http://schemas.openxmlformats.org/presentationml/2006/main" show="0">
+  <p:cSld>
+    <p:bg>
+      <p:bgPr>
+        <a:solidFill>
+          <a:schemeClr val="bg1"/>
+        </a:solidFill>
+        <a:effectLst/>
+      </p:bgPr>
+    </p:bg>
+    <p:spTree>
+      <p:nvGrpSpPr>
+        <p:cNvPr id="1" name="">
+          <a:extLst>
+            <a:ext uri="{FF2B5EF4-FFF2-40B4-BE49-F238E27FC236}">
+              <a16:creationId xmlns:a16="http://schemas.microsoft.com/office/drawing/2014/main" id="{1CE65C8C-8D12-9A18-4A9A-7F24FA03AA2E}"/>
+            </a:ext>
+          </a:extLst>
+        </p:cNvPr>
+        <p:cNvGrpSpPr/>
+        <p:nvPr/>
+      </p:nvGrpSpPr>
+      <p:grpSpPr>
+        <a:xfrm>
+          <a:off x="0" y="0"/>
+          <a:ext cx="0" cy="0"/>
+          <a:chOff x="0" y="0"/>
+          <a:chExt cx="0" cy="0"/>
+        </a:xfrm>
+      </p:grpSpPr>
+      <p:sp useBgFill="1">
+        <p:nvSpPr>
+          <p:cNvPr id="10" name="Rectangle 9">
+            <a:extLst>
+              <a:ext uri="{FF2B5EF4-FFF2-40B4-BE49-F238E27FC236}">
+                <a16:creationId xmlns:a16="http://schemas.microsoft.com/office/drawing/2014/main" id="{B0388AAC-3ADC-4C99-101E-BBE738C1C8B1}"/>
+              </a:ext>
+              <a:ext uri="{C183D7F6-B498-43B3-948B-1728B52AA6E4}">
+                <adec:decorative xmlns:adec="http://schemas.microsoft.com/office/drawing/2017/decorative" val="1"/>
+              </a:ext>
+            </a:extLst>
+          </p:cNvPr>
+          <p:cNvSpPr>
+            <a:spLocks noGrp="1" noRot="1" noChangeAspect="1" noMove="1" noResize="1" noEditPoints="1" noAdjustHandles="1" noChangeArrowheads="1" noChangeShapeType="1" noTextEdit="1"/>
+          </p:cNvSpPr>
+          <p:nvPr>
+            <p:extLst>
+              <p:ext uri="{386F3935-93C4-4BCD-93E2-E3B085C9AB24}">
+                <p16:designElem xmlns:p16="http://schemas.microsoft.com/office/powerpoint/2015/main" val="1"/>
+              </p:ext>
+            </p:extLst>
+          </p:nvPr>
+        </p:nvSpPr>
+        <p:spPr>
+          <a:xfrm>
+            <a:off x="0" y="0"/>
+            <a:ext cx="12192000" cy="6858000"/>
+          </a:xfrm>
+          <a:prstGeom prst="rect">
+            <a:avLst/>
+          </a:prstGeom>
+          <a:ln w="12700" cap="flat" cmpd="sng" algn="ctr">
+            <a:noFill/>
+            <a:prstDash val="solid"/>
+            <a:miter lim="800000"/>
+          </a:ln>
+          <a:effectLst/>
+          <a:extLst>
+            <a:ext uri="{91240B29-F687-4F45-9708-019B960494DF}">
+              <a14:hiddenLine xmlns:a14="http://schemas.microsoft.com/office/drawing/2010/main" w="12700" cap="flat" cmpd="sng" algn="ctr">
+                <a:solidFill>
+                  <a:schemeClr val="accent1">
+                    <a:shade val="50000"/>
+                  </a:schemeClr>
+                </a:solidFill>
+                <a:prstDash val="solid"/>
+                <a:miter lim="800000"/>
+              </a14:hiddenLine>
+            </a:ext>
+          </a:extLst>
+        </p:spPr>
+        <p:style>
+          <a:lnRef idx="2">
+            <a:schemeClr val="accent1">
+              <a:shade val="50000"/>
+            </a:schemeClr>
+          </a:lnRef>
+          <a:fillRef idx="1">
+            <a:schemeClr val="accent1"/>
+          </a:fillRef>
+          <a:effectRef idx="0">
+            <a:schemeClr val="accent1"/>
+          </a:effectRef>
+          <a:fontRef idx="minor">
+            <a:schemeClr val="lt1"/>
+          </a:fontRef>
+        </p:style>
+        <p:txBody>
+          <a:bodyPr rtlCol="0" anchor="ctr"/>
+          <a:lstStyle/>
+          <a:p>
+            <a:pPr algn="ctr"/>
+            <a:endParaRPr lang="en-US"/>
+          </a:p>
+        </p:txBody>
+      </p:sp>
+      <p:sp>
+        <p:nvSpPr>
+          <p:cNvPr id="12" name="Rectangle 11">
+            <a:extLst>
+              <a:ext uri="{FF2B5EF4-FFF2-40B4-BE49-F238E27FC236}">
+                <a16:creationId xmlns:a16="http://schemas.microsoft.com/office/drawing/2014/main" id="{10F6C16A-4517-4FB5-22BE-F009DA915AF9}"/>
+              </a:ext>
+              <a:ext uri="{C183D7F6-B498-43B3-948B-1728B52AA6E4}">
+                <adec:decorative xmlns:adec="http://schemas.microsoft.com/office/drawing/2017/decorative" val="1"/>
+              </a:ext>
+            </a:extLst>
+          </p:cNvPr>
+          <p:cNvSpPr>
+            <a:spLocks noGrp="1" noRot="1" noChangeAspect="1" noMove="1" noResize="1" noEditPoints="1" noAdjustHandles="1" noChangeArrowheads="1" noChangeShapeType="1" noTextEdit="1"/>
+          </p:cNvSpPr>
+          <p:nvPr>
+            <p:extLst>
+              <p:ext uri="{386F3935-93C4-4BCD-93E2-E3B085C9AB24}">
+                <p16:designElem xmlns:p16="http://schemas.microsoft.com/office/powerpoint/2015/main" val="1"/>
+              </p:ext>
+            </p:extLst>
+          </p:nvPr>
+        </p:nvSpPr>
+        <p:spPr>
+          <a:xfrm rot="10800000" flipH="1">
+            <a:off x="2" y="0"/>
+            <a:ext cx="12191998" cy="1575955"/>
+          </a:xfrm>
+          <a:prstGeom prst="rect">
+            <a:avLst/>
+          </a:prstGeom>
+          <a:gradFill>
+            <a:gsLst>
+              <a:gs pos="0">
+                <a:srgbClr val="000000">
+                  <a:alpha val="96000"/>
+                </a:srgbClr>
+              </a:gs>
+              <a:gs pos="100000">
+                <a:schemeClr val="accent1">
+                  <a:lumMod val="75000"/>
+                </a:schemeClr>
+              </a:gs>
+            </a:gsLst>
+            <a:lin ang="6000000" scaled="0"/>
+          </a:gradFill>
+          <a:ln>
+            <a:noFill/>
+          </a:ln>
+        </p:spPr>
+        <p:style>
+          <a:lnRef idx="2">
+            <a:schemeClr val="accent1">
+              <a:shade val="50000"/>
+            </a:schemeClr>
+          </a:lnRef>
+          <a:fillRef idx="1">
+            <a:schemeClr val="accent1"/>
+          </a:fillRef>
+          <a:effectRef idx="0">
+            <a:schemeClr val="accent1"/>
+          </a:effectRef>
+          <a:fontRef idx="minor">
+            <a:schemeClr val="lt1"/>
+          </a:fontRef>
+        </p:style>
+        <p:txBody>
+          <a:bodyPr rtlCol="0" anchor="ctr"/>
+          <a:lstStyle/>
+          <a:p>
+            <a:pPr algn="ctr"/>
+            <a:endParaRPr lang="en-US"/>
+          </a:p>
+        </p:txBody>
+      </p:sp>
+      <p:sp>
+        <p:nvSpPr>
+          <p:cNvPr id="14" name="Rectangle 13">
+            <a:extLst>
+              <a:ext uri="{FF2B5EF4-FFF2-40B4-BE49-F238E27FC236}">
+                <a16:creationId xmlns:a16="http://schemas.microsoft.com/office/drawing/2014/main" id="{4ECDD89C-570F-36A9-BF7F-F81FF36C944F}"/>
+              </a:ext>
+              <a:ext uri="{C183D7F6-B498-43B3-948B-1728B52AA6E4}">
+                <adec:decorative xmlns:adec="http://schemas.microsoft.com/office/drawing/2017/decorative" val="1"/>
+              </a:ext>
+            </a:extLst>
+          </p:cNvPr>
+          <p:cNvSpPr>
+            <a:spLocks noGrp="1" noRot="1" noChangeAspect="1" noMove="1" noResize="1" noEditPoints="1" noAdjustHandles="1" noChangeArrowheads="1" noChangeShapeType="1" noTextEdit="1"/>
+          </p:cNvSpPr>
+          <p:nvPr>
+            <p:extLst>
+              <p:ext uri="{386F3935-93C4-4BCD-93E2-E3B085C9AB24}">
+                <p16:designElem xmlns:p16="http://schemas.microsoft.com/office/powerpoint/2015/main" val="1"/>
+              </p:ext>
+            </p:extLst>
+          </p:nvPr>
+        </p:nvSpPr>
+        <p:spPr>
+          <a:xfrm>
+            <a:off x="0" y="0"/>
+            <a:ext cx="8128856" cy="1575461"/>
+          </a:xfrm>
+          <a:prstGeom prst="rect">
+            <a:avLst/>
+          </a:prstGeom>
+          <a:gradFill>
+            <a:gsLst>
+              <a:gs pos="0">
+                <a:schemeClr val="accent1">
+                  <a:alpha val="41000"/>
+                </a:schemeClr>
+              </a:gs>
+              <a:gs pos="74000">
+                <a:schemeClr val="accent1">
+                  <a:lumMod val="60000"/>
+                  <a:lumOff val="40000"/>
+                  <a:alpha val="0"/>
+                </a:schemeClr>
+              </a:gs>
+            </a:gsLst>
+            <a:lin ang="8400000" scaled="0"/>
+          </a:gradFill>
+          <a:ln>
+            <a:noFill/>
+          </a:ln>
+        </p:spPr>
+        <p:style>
+          <a:lnRef idx="2">
+            <a:schemeClr val="accent1">
+              <a:shade val="50000"/>
+            </a:schemeClr>
+          </a:lnRef>
+          <a:fillRef idx="1">
+            <a:schemeClr val="accent1"/>
+          </a:fillRef>
+          <a:effectRef idx="0">
+            <a:schemeClr val="accent1"/>
+          </a:effectRef>
+          <a:fontRef idx="minor">
+            <a:schemeClr val="lt1"/>
+          </a:fontRef>
+        </p:style>
+        <p:txBody>
+          <a:bodyPr rtlCol="0" anchor="ctr"/>
+          <a:lstStyle/>
+          <a:p>
+            <a:pPr algn="ctr"/>
+            <a:endParaRPr lang="en-US"/>
+          </a:p>
+        </p:txBody>
+      </p:sp>
+      <p:sp>
+        <p:nvSpPr>
+          <p:cNvPr id="16" name="Rectangle 15">
+            <a:extLst>
+              <a:ext uri="{FF2B5EF4-FFF2-40B4-BE49-F238E27FC236}">
+                <a16:creationId xmlns:a16="http://schemas.microsoft.com/office/drawing/2014/main" id="{DED9CA6F-9682-A7A8-F411-6819E2556989}"/>
+              </a:ext>
+              <a:ext uri="{C183D7F6-B498-43B3-948B-1728B52AA6E4}">
+                <adec:decorative xmlns:adec="http://schemas.microsoft.com/office/drawing/2017/decorative" val="1"/>
+              </a:ext>
+            </a:extLst>
+          </p:cNvPr>
+          <p:cNvSpPr>
+            <a:spLocks noGrp="1" noRot="1" noChangeAspect="1" noMove="1" noResize="1" noEditPoints="1" noAdjustHandles="1" noChangeArrowheads="1" noChangeShapeType="1" noTextEdit="1"/>
+          </p:cNvSpPr>
+          <p:nvPr>
+            <p:extLst>
+              <p:ext uri="{386F3935-93C4-4BCD-93E2-E3B085C9AB24}">
+                <p16:designElem xmlns:p16="http://schemas.microsoft.com/office/powerpoint/2015/main" val="1"/>
+              </p:ext>
+            </p:extLst>
+          </p:nvPr>
+        </p:nvSpPr>
+        <p:spPr>
+          <a:xfrm flipH="1">
+            <a:off x="-3" y="-1"/>
+            <a:ext cx="12192002" cy="1574311"/>
+          </a:xfrm>
+          <a:prstGeom prst="rect">
+            <a:avLst/>
+          </a:prstGeom>
+          <a:gradFill>
+            <a:gsLst>
+              <a:gs pos="0">
+                <a:srgbClr val="000000">
+                  <a:alpha val="63000"/>
+                </a:srgbClr>
+              </a:gs>
+              <a:gs pos="78000">
+                <a:schemeClr val="accent1">
+                  <a:alpha val="15000"/>
+                </a:schemeClr>
+              </a:gs>
+            </a:gsLst>
+            <a:lin ang="15600000" scaled="0"/>
+          </a:gradFill>
+          <a:ln>
+            <a:noFill/>
+          </a:ln>
+        </p:spPr>
+        <p:style>
+          <a:lnRef idx="2">
+            <a:schemeClr val="accent1">
+              <a:shade val="50000"/>
+            </a:schemeClr>
+          </a:lnRef>
+          <a:fillRef idx="1">
+            <a:schemeClr val="accent1"/>
+          </a:fillRef>
+          <a:effectRef idx="0">
+            <a:schemeClr val="accent1"/>
+          </a:effectRef>
+          <a:fontRef idx="minor">
+            <a:schemeClr val="lt1"/>
+          </a:fontRef>
+        </p:style>
+        <p:txBody>
+          <a:bodyPr rtlCol="0" anchor="ctr"/>
+          <a:lstStyle/>
+          <a:p>
+            <a:pPr algn="ctr"/>
+            <a:endParaRPr lang="en-US"/>
+          </a:p>
+        </p:txBody>
+      </p:sp>
+      <p:sp>
+        <p:nvSpPr>
+          <p:cNvPr id="2" name="Title 1">
+            <a:extLst>
+              <a:ext uri="{FF2B5EF4-FFF2-40B4-BE49-F238E27FC236}">
                 <a16:creationId xmlns:a16="http://schemas.microsoft.com/office/drawing/2014/main" id="{10E393B6-162A-D05A-0CDA-B6670E467300}"/>
               </a:ext>
             </a:extLst>
@@ -8958,7 +9596,7 @@
 </p:sld>
 </file>
 
-<file path=ppt/slides/slide13.xml><?xml version="1.0" encoding="utf-8"?>
+<file path=ppt/slides/slide14.xml><?xml version="1.0" encoding="utf-8"?>
 <p:sld xmlns:a="http://schemas.openxmlformats.org/drawingml/2006/main" xmlns:r="http://schemas.openxmlformats.org/officeDocument/2006/relationships" xmlns:p="http://schemas.openxmlformats.org/presentationml/2006/main">
   <p:cSld>
     <p:bg>
@@ -9631,7 +10269,7 @@
 </p:sld>
 </file>
 
-<file path=ppt/slides/slide14.xml><?xml version="1.0" encoding="utf-8"?>
+<file path=ppt/slides/slide15.xml><?xml version="1.0" encoding="utf-8"?>
 <p:sld xmlns:a="http://schemas.openxmlformats.org/drawingml/2006/main" xmlns:r="http://schemas.openxmlformats.org/officeDocument/2006/relationships" xmlns:p="http://schemas.openxmlformats.org/presentationml/2006/main">
   <p:cSld>
     <p:bg>
@@ -10255,7 +10893,7 @@
 </p:sld>
 </file>
 
-<file path=ppt/slides/slide15.xml><?xml version="1.0" encoding="utf-8"?>
+<file path=ppt/slides/slide16.xml><?xml version="1.0" encoding="utf-8"?>
 <p:sld xmlns:a="http://schemas.openxmlformats.org/drawingml/2006/main" xmlns:r="http://schemas.openxmlformats.org/officeDocument/2006/relationships" xmlns:p="http://schemas.openxmlformats.org/presentationml/2006/main">
   <p:cSld>
     <p:bg>
@@ -11165,7 +11803,7 @@
 </p:sld>
 </file>
 
-<file path=ppt/slides/slide16.xml><?xml version="1.0" encoding="utf-8"?>
+<file path=ppt/slides/slide17.xml><?xml version="1.0" encoding="utf-8"?>
 <p:sld xmlns:a="http://schemas.openxmlformats.org/drawingml/2006/main" xmlns:r="http://schemas.openxmlformats.org/officeDocument/2006/relationships" xmlns:p="http://schemas.openxmlformats.org/presentationml/2006/main">
   <p:cSld>
     <p:bg>
@@ -12018,7 +12656,7 @@
 </p:sld>
 </file>
 
-<file path=ppt/slides/slide17.xml><?xml version="1.0" encoding="utf-8"?>
+<file path=ppt/slides/slide18.xml><?xml version="1.0" encoding="utf-8"?>
 <p:sld xmlns:a="http://schemas.openxmlformats.org/drawingml/2006/main" xmlns:r="http://schemas.openxmlformats.org/officeDocument/2006/relationships" xmlns:p="http://schemas.openxmlformats.org/presentationml/2006/main">
   <p:cSld>
     <p:bg>
@@ -13170,7 +13808,7 @@
 </p:sld>
 </file>
 
-<file path=ppt/slides/slide18.xml><?xml version="1.0" encoding="utf-8"?>
+<file path=ppt/slides/slide19.xml><?xml version="1.0" encoding="utf-8"?>
 <p:sld xmlns:a="http://schemas.openxmlformats.org/drawingml/2006/main" xmlns:r="http://schemas.openxmlformats.org/officeDocument/2006/relationships" xmlns:p="http://schemas.openxmlformats.org/presentationml/2006/main">
   <p:cSld>
     <p:bg>
@@ -13548,10 +14186,10 @@
       </p:sp>
       <p:pic>
         <p:nvPicPr>
-          <p:cNvPr id="4" name="Picture 3">
-            <a:extLst>
-              <a:ext uri="{FF2B5EF4-FFF2-40B4-BE49-F238E27FC236}">
-                <a16:creationId xmlns:a16="http://schemas.microsoft.com/office/drawing/2014/main" id="{6A6F99C5-2DE6-DC3E-B811-F64C9C810134}"/>
+          <p:cNvPr id="5" name="Picture 4">
+            <a:extLst>
+              <a:ext uri="{FF2B5EF4-FFF2-40B4-BE49-F238E27FC236}">
+                <a16:creationId xmlns:a16="http://schemas.microsoft.com/office/drawing/2014/main" id="{A638BBA1-023E-5330-CF0F-D4D8744D1929}"/>
               </a:ext>
             </a:extLst>
           </p:cNvPr>
@@ -13568,8 +14206,8 @@
         </p:blipFill>
         <p:spPr>
           <a:xfrm>
-            <a:off x="0" y="2080006"/>
-            <a:ext cx="12192000" cy="3835907"/>
+            <a:off x="-3" y="1798000"/>
+            <a:ext cx="12192000" cy="4811962"/>
           </a:xfrm>
           <a:prstGeom prst="rect">
             <a:avLst/>
@@ -13589,8 +14227,8 @@
 </p:sld>
 </file>
 
-<file path=ppt/slides/slide19.xml><?xml version="1.0" encoding="utf-8"?>
-<p:sld xmlns:a="http://schemas.openxmlformats.org/drawingml/2006/main" xmlns:r="http://schemas.openxmlformats.org/officeDocument/2006/relationships" xmlns:p="http://schemas.openxmlformats.org/presentationml/2006/main" show="0">
+<file path=ppt/slides/slide2.xml><?xml version="1.0" encoding="utf-8"?>
+<p:sld xmlns:a="http://schemas.openxmlformats.org/drawingml/2006/main" xmlns:r="http://schemas.openxmlformats.org/officeDocument/2006/relationships" xmlns:p="http://schemas.openxmlformats.org/presentationml/2006/main">
   <p:cSld>
     <p:bg>
       <p:bgPr>
@@ -13995,7 +14633,7 @@
           <p:cNvPr id="2" name="Title 1">
             <a:extLst>
               <a:ext uri="{FF2B5EF4-FFF2-40B4-BE49-F238E27FC236}">
-                <a16:creationId xmlns:a16="http://schemas.microsoft.com/office/drawing/2014/main" id="{ED9ECE6E-66C4-96BE-76E0-E8395F0AC9DA}"/>
+                <a16:creationId xmlns:a16="http://schemas.microsoft.com/office/drawing/2014/main" id="{27D0DF9F-1E2D-5CFD-D2E6-89F1ED1AAC63}"/>
               </a:ext>
             </a:extLst>
           </p:cNvPr>
@@ -14024,47 +14662,50 @@
                   <a:srgbClr val="FFFFFF"/>
                 </a:solidFill>
               </a:rPr>
-              <a:t>Overall View</a:t>
-            </a:r>
-          </a:p>
-        </p:txBody>
-      </p:sp>
-      <p:sp>
-        <p:nvSpPr>
-          <p:cNvPr id="3" name="Content Placeholder 2">
-            <a:extLst>
-              <a:ext uri="{FF2B5EF4-FFF2-40B4-BE49-F238E27FC236}">
-                <a16:creationId xmlns:a16="http://schemas.microsoft.com/office/drawing/2014/main" id="{98C9873B-F462-4550-D847-5493A0F7F3D8}"/>
-              </a:ext>
-            </a:extLst>
-          </p:cNvPr>
-          <p:cNvSpPr>
-            <a:spLocks noGrp="1"/>
-          </p:cNvSpPr>
+              <a:t>General architecture (Testing based on)</a:t>
+            </a:r>
+          </a:p>
+        </p:txBody>
+      </p:sp>
+      <p:pic>
+        <p:nvPicPr>
+          <p:cNvPr id="5" name="Content Placeholder 4" descr="A group of white rectangular shapes with black text&#10;&#10;AI-generated content may be incorrect.">
+            <a:extLst>
+              <a:ext uri="{FF2B5EF4-FFF2-40B4-BE49-F238E27FC236}">
+                <a16:creationId xmlns:a16="http://schemas.microsoft.com/office/drawing/2014/main" id="{14E12D97-A3DA-867A-2F05-623C660A7994}"/>
+              </a:ext>
+            </a:extLst>
+          </p:cNvPr>
+          <p:cNvPicPr>
+            <a:picLocks noGrp="1" noChangeAspect="1"/>
+          </p:cNvPicPr>
           <p:nvPr>
             <p:ph idx="1"/>
           </p:nvPr>
-        </p:nvSpPr>
+        </p:nvPicPr>
+        <p:blipFill>
+          <a:blip r:embed="rId2">
+            <a:extLst>
+              <a:ext uri="{28A0092B-C50C-407E-A947-70E740481C1C}">
+                <a14:useLocalDpi xmlns:a14="http://schemas.microsoft.com/office/drawing/2010/main" val="0"/>
+              </a:ext>
+            </a:extLst>
+          </a:blip>
+          <a:stretch>
+            <a:fillRect/>
+          </a:stretch>
+        </p:blipFill>
         <p:spPr>
           <a:xfrm>
-            <a:off x="1371599" y="2318197"/>
-            <a:ext cx="9724031" cy="3683358"/>
+            <a:off x="2209720" y="1976106"/>
+            <a:ext cx="7772560" cy="4373334"/>
           </a:xfrm>
         </p:spPr>
-        <p:txBody>
-          <a:bodyPr anchor="ctr">
-            <a:normAutofit/>
-          </a:bodyPr>
-          <a:lstStyle/>
-          <a:p>
-            <a:endParaRPr lang="en-US" sz="2000"/>
-          </a:p>
-        </p:txBody>
-      </p:sp>
+      </p:pic>
     </p:spTree>
     <p:extLst>
       <p:ext uri="{BB962C8B-B14F-4D97-AF65-F5344CB8AC3E}">
-        <p14:creationId xmlns:p14="http://schemas.microsoft.com/office/powerpoint/2010/main" val="1828056376"/>
+        <p14:creationId xmlns:p14="http://schemas.microsoft.com/office/powerpoint/2010/main" val="1308577209"/>
       </p:ext>
     </p:extLst>
   </p:cSld>
@@ -14074,8 +14715,8 @@
 </p:sld>
 </file>
 
-<file path=ppt/slides/slide2.xml><?xml version="1.0" encoding="utf-8"?>
-<p:sld xmlns:a="http://schemas.openxmlformats.org/drawingml/2006/main" xmlns:r="http://schemas.openxmlformats.org/officeDocument/2006/relationships" xmlns:p="http://schemas.openxmlformats.org/presentationml/2006/main">
+<file path=ppt/slides/slide20.xml><?xml version="1.0" encoding="utf-8"?>
+<p:sld xmlns:a="http://schemas.openxmlformats.org/drawingml/2006/main" xmlns:r="http://schemas.openxmlformats.org/officeDocument/2006/relationships" xmlns:p="http://schemas.openxmlformats.org/presentationml/2006/main" show="0">
   <p:cSld>
     <p:bg>
       <p:bgPr>
@@ -14087,7 +14728,13 @@
     </p:bg>
     <p:spTree>
       <p:nvGrpSpPr>
-        <p:cNvPr id="1" name=""/>
+        <p:cNvPr id="1" name="">
+          <a:extLst>
+            <a:ext uri="{FF2B5EF4-FFF2-40B4-BE49-F238E27FC236}">
+              <a16:creationId xmlns:a16="http://schemas.microsoft.com/office/drawing/2014/main" id="{41D38F42-88D3-B089-E183-FB0241D46E6E}"/>
+            </a:ext>
+          </a:extLst>
+        </p:cNvPr>
         <p:cNvGrpSpPr/>
         <p:nvPr/>
       </p:nvGrpSpPr>
@@ -14101,10 +14748,10 @@
       </p:grpSpPr>
       <p:sp useBgFill="1">
         <p:nvSpPr>
-          <p:cNvPr id="8" name="Rectangle 7">
-            <a:extLst>
-              <a:ext uri="{FF2B5EF4-FFF2-40B4-BE49-F238E27FC236}">
-                <a16:creationId xmlns:a16="http://schemas.microsoft.com/office/drawing/2014/main" id="{1B15ED52-F352-441B-82BF-E0EA34836D08}"/>
+          <p:cNvPr id="10" name="Rectangle 9">
+            <a:extLst>
+              <a:ext uri="{FF2B5EF4-FFF2-40B4-BE49-F238E27FC236}">
+                <a16:creationId xmlns:a16="http://schemas.microsoft.com/office/drawing/2014/main" id="{73B3D364-EE43-9632-34EB-23277285FBBE}"/>
               </a:ext>
               <a:ext uri="{C183D7F6-B498-43B3-948B-1728B52AA6E4}">
                 <adec:decorative xmlns:adec="http://schemas.microsoft.com/office/drawing/2017/decorative" val="1"/>
@@ -14177,6 +14824,419 @@
       </p:sp>
       <p:sp>
         <p:nvSpPr>
+          <p:cNvPr id="12" name="Rectangle 11">
+            <a:extLst>
+              <a:ext uri="{FF2B5EF4-FFF2-40B4-BE49-F238E27FC236}">
+                <a16:creationId xmlns:a16="http://schemas.microsoft.com/office/drawing/2014/main" id="{BAFDD2AE-3214-4BFF-802F-C3F2C8645267}"/>
+              </a:ext>
+              <a:ext uri="{C183D7F6-B498-43B3-948B-1728B52AA6E4}">
+                <adec:decorative xmlns:adec="http://schemas.microsoft.com/office/drawing/2017/decorative" val="1"/>
+              </a:ext>
+            </a:extLst>
+          </p:cNvPr>
+          <p:cNvSpPr>
+            <a:spLocks noGrp="1" noRot="1" noChangeAspect="1" noMove="1" noResize="1" noEditPoints="1" noAdjustHandles="1" noChangeArrowheads="1" noChangeShapeType="1" noTextEdit="1"/>
+          </p:cNvSpPr>
+          <p:nvPr>
+            <p:extLst>
+              <p:ext uri="{386F3935-93C4-4BCD-93E2-E3B085C9AB24}">
+                <p16:designElem xmlns:p16="http://schemas.microsoft.com/office/powerpoint/2015/main" val="1"/>
+              </p:ext>
+            </p:extLst>
+          </p:nvPr>
+        </p:nvSpPr>
+        <p:spPr>
+          <a:xfrm rot="10800000" flipH="1">
+            <a:off x="2" y="0"/>
+            <a:ext cx="12191998" cy="1575955"/>
+          </a:xfrm>
+          <a:prstGeom prst="rect">
+            <a:avLst/>
+          </a:prstGeom>
+          <a:gradFill>
+            <a:gsLst>
+              <a:gs pos="0">
+                <a:srgbClr val="000000">
+                  <a:alpha val="96000"/>
+                </a:srgbClr>
+              </a:gs>
+              <a:gs pos="100000">
+                <a:schemeClr val="accent1">
+                  <a:lumMod val="75000"/>
+                </a:schemeClr>
+              </a:gs>
+            </a:gsLst>
+            <a:lin ang="6000000" scaled="0"/>
+          </a:gradFill>
+          <a:ln>
+            <a:noFill/>
+          </a:ln>
+        </p:spPr>
+        <p:style>
+          <a:lnRef idx="2">
+            <a:schemeClr val="accent1">
+              <a:shade val="50000"/>
+            </a:schemeClr>
+          </a:lnRef>
+          <a:fillRef idx="1">
+            <a:schemeClr val="accent1"/>
+          </a:fillRef>
+          <a:effectRef idx="0">
+            <a:schemeClr val="accent1"/>
+          </a:effectRef>
+          <a:fontRef idx="minor">
+            <a:schemeClr val="lt1"/>
+          </a:fontRef>
+        </p:style>
+        <p:txBody>
+          <a:bodyPr rtlCol="0" anchor="ctr"/>
+          <a:lstStyle/>
+          <a:p>
+            <a:pPr algn="ctr"/>
+            <a:endParaRPr lang="en-US"/>
+          </a:p>
+        </p:txBody>
+      </p:sp>
+      <p:sp>
+        <p:nvSpPr>
+          <p:cNvPr id="14" name="Rectangle 13">
+            <a:extLst>
+              <a:ext uri="{FF2B5EF4-FFF2-40B4-BE49-F238E27FC236}">
+                <a16:creationId xmlns:a16="http://schemas.microsoft.com/office/drawing/2014/main" id="{7968EEC1-EDC9-1CA2-E242-393EAFA81384}"/>
+              </a:ext>
+              <a:ext uri="{C183D7F6-B498-43B3-948B-1728B52AA6E4}">
+                <adec:decorative xmlns:adec="http://schemas.microsoft.com/office/drawing/2017/decorative" val="1"/>
+              </a:ext>
+            </a:extLst>
+          </p:cNvPr>
+          <p:cNvSpPr>
+            <a:spLocks noGrp="1" noRot="1" noChangeAspect="1" noMove="1" noResize="1" noEditPoints="1" noAdjustHandles="1" noChangeArrowheads="1" noChangeShapeType="1" noTextEdit="1"/>
+          </p:cNvSpPr>
+          <p:nvPr>
+            <p:extLst>
+              <p:ext uri="{386F3935-93C4-4BCD-93E2-E3B085C9AB24}">
+                <p16:designElem xmlns:p16="http://schemas.microsoft.com/office/powerpoint/2015/main" val="1"/>
+              </p:ext>
+            </p:extLst>
+          </p:nvPr>
+        </p:nvSpPr>
+        <p:spPr>
+          <a:xfrm>
+            <a:off x="0" y="0"/>
+            <a:ext cx="8128856" cy="1575461"/>
+          </a:xfrm>
+          <a:prstGeom prst="rect">
+            <a:avLst/>
+          </a:prstGeom>
+          <a:gradFill>
+            <a:gsLst>
+              <a:gs pos="0">
+                <a:schemeClr val="accent1">
+                  <a:alpha val="41000"/>
+                </a:schemeClr>
+              </a:gs>
+              <a:gs pos="74000">
+                <a:schemeClr val="accent1">
+                  <a:lumMod val="60000"/>
+                  <a:lumOff val="40000"/>
+                  <a:alpha val="0"/>
+                </a:schemeClr>
+              </a:gs>
+            </a:gsLst>
+            <a:lin ang="8400000" scaled="0"/>
+          </a:gradFill>
+          <a:ln>
+            <a:noFill/>
+          </a:ln>
+        </p:spPr>
+        <p:style>
+          <a:lnRef idx="2">
+            <a:schemeClr val="accent1">
+              <a:shade val="50000"/>
+            </a:schemeClr>
+          </a:lnRef>
+          <a:fillRef idx="1">
+            <a:schemeClr val="accent1"/>
+          </a:fillRef>
+          <a:effectRef idx="0">
+            <a:schemeClr val="accent1"/>
+          </a:effectRef>
+          <a:fontRef idx="minor">
+            <a:schemeClr val="lt1"/>
+          </a:fontRef>
+        </p:style>
+        <p:txBody>
+          <a:bodyPr rtlCol="0" anchor="ctr"/>
+          <a:lstStyle/>
+          <a:p>
+            <a:pPr algn="ctr"/>
+            <a:endParaRPr lang="en-US"/>
+          </a:p>
+        </p:txBody>
+      </p:sp>
+      <p:sp>
+        <p:nvSpPr>
+          <p:cNvPr id="16" name="Rectangle 15">
+            <a:extLst>
+              <a:ext uri="{FF2B5EF4-FFF2-40B4-BE49-F238E27FC236}">
+                <a16:creationId xmlns:a16="http://schemas.microsoft.com/office/drawing/2014/main" id="{69F7FB9D-1473-4D9F-262D-767A15595780}"/>
+              </a:ext>
+              <a:ext uri="{C183D7F6-B498-43B3-948B-1728B52AA6E4}">
+                <adec:decorative xmlns:adec="http://schemas.microsoft.com/office/drawing/2017/decorative" val="1"/>
+              </a:ext>
+            </a:extLst>
+          </p:cNvPr>
+          <p:cNvSpPr>
+            <a:spLocks noGrp="1" noRot="1" noChangeAspect="1" noMove="1" noResize="1" noEditPoints="1" noAdjustHandles="1" noChangeArrowheads="1" noChangeShapeType="1" noTextEdit="1"/>
+          </p:cNvSpPr>
+          <p:nvPr>
+            <p:extLst>
+              <p:ext uri="{386F3935-93C4-4BCD-93E2-E3B085C9AB24}">
+                <p16:designElem xmlns:p16="http://schemas.microsoft.com/office/powerpoint/2015/main" val="1"/>
+              </p:ext>
+            </p:extLst>
+          </p:nvPr>
+        </p:nvSpPr>
+        <p:spPr>
+          <a:xfrm flipH="1">
+            <a:off x="-3" y="-1"/>
+            <a:ext cx="12192002" cy="1574311"/>
+          </a:xfrm>
+          <a:prstGeom prst="rect">
+            <a:avLst/>
+          </a:prstGeom>
+          <a:gradFill>
+            <a:gsLst>
+              <a:gs pos="0">
+                <a:srgbClr val="000000">
+                  <a:alpha val="63000"/>
+                </a:srgbClr>
+              </a:gs>
+              <a:gs pos="78000">
+                <a:schemeClr val="accent1">
+                  <a:alpha val="15000"/>
+                </a:schemeClr>
+              </a:gs>
+            </a:gsLst>
+            <a:lin ang="15600000" scaled="0"/>
+          </a:gradFill>
+          <a:ln>
+            <a:noFill/>
+          </a:ln>
+        </p:spPr>
+        <p:style>
+          <a:lnRef idx="2">
+            <a:schemeClr val="accent1">
+              <a:shade val="50000"/>
+            </a:schemeClr>
+          </a:lnRef>
+          <a:fillRef idx="1">
+            <a:schemeClr val="accent1"/>
+          </a:fillRef>
+          <a:effectRef idx="0">
+            <a:schemeClr val="accent1"/>
+          </a:effectRef>
+          <a:fontRef idx="minor">
+            <a:schemeClr val="lt1"/>
+          </a:fontRef>
+        </p:style>
+        <p:txBody>
+          <a:bodyPr rtlCol="0" anchor="ctr"/>
+          <a:lstStyle/>
+          <a:p>
+            <a:pPr algn="ctr"/>
+            <a:endParaRPr lang="en-US"/>
+          </a:p>
+        </p:txBody>
+      </p:sp>
+      <p:sp>
+        <p:nvSpPr>
+          <p:cNvPr id="2" name="Title 1">
+            <a:extLst>
+              <a:ext uri="{FF2B5EF4-FFF2-40B4-BE49-F238E27FC236}">
+                <a16:creationId xmlns:a16="http://schemas.microsoft.com/office/drawing/2014/main" id="{2717C351-71D7-5E9C-6891-EBB6B31C063A}"/>
+              </a:ext>
+            </a:extLst>
+          </p:cNvPr>
+          <p:cNvSpPr>
+            <a:spLocks noGrp="1"/>
+          </p:cNvSpPr>
+          <p:nvPr>
+            <p:ph type="title"/>
+          </p:nvPr>
+        </p:nvSpPr>
+        <p:spPr>
+          <a:xfrm>
+            <a:off x="699713" y="248038"/>
+            <a:ext cx="7063721" cy="1159200"/>
+          </a:xfrm>
+        </p:spPr>
+        <p:txBody>
+          <a:bodyPr vert="horz" lIns="91440" tIns="45720" rIns="91440" bIns="45720" rtlCol="0" anchor="ctr">
+            <a:normAutofit/>
+          </a:bodyPr>
+          <a:lstStyle/>
+          <a:p>
+            <a:r>
+              <a:rPr lang="en-US" sz="4000" kern="1200">
+                <a:solidFill>
+                  <a:srgbClr val="FFFFFF"/>
+                </a:solidFill>
+                <a:latin typeface="+mj-lt"/>
+                <a:ea typeface="+mj-ea"/>
+                <a:cs typeface="+mj-cs"/>
+              </a:rPr>
+              <a:t>Overall View</a:t>
+            </a:r>
+          </a:p>
+        </p:txBody>
+      </p:sp>
+      <p:pic>
+        <p:nvPicPr>
+          <p:cNvPr id="4" name="Picture 3">
+            <a:extLst>
+              <a:ext uri="{FF2B5EF4-FFF2-40B4-BE49-F238E27FC236}">
+                <a16:creationId xmlns:a16="http://schemas.microsoft.com/office/drawing/2014/main" id="{505CEF2F-692B-64F2-4565-98BE9D9EDA64}"/>
+              </a:ext>
+            </a:extLst>
+          </p:cNvPr>
+          <p:cNvPicPr>
+            <a:picLocks noChangeAspect="1"/>
+          </p:cNvPicPr>
+          <p:nvPr/>
+        </p:nvPicPr>
+        <p:blipFill>
+          <a:blip r:embed="rId3"/>
+          <a:stretch>
+            <a:fillRect/>
+          </a:stretch>
+        </p:blipFill>
+        <p:spPr>
+          <a:xfrm>
+            <a:off x="0" y="2080006"/>
+            <a:ext cx="12192000" cy="3835907"/>
+          </a:xfrm>
+          <a:prstGeom prst="rect">
+            <a:avLst/>
+          </a:prstGeom>
+        </p:spPr>
+      </p:pic>
+    </p:spTree>
+    <p:extLst>
+      <p:ext uri="{BB962C8B-B14F-4D97-AF65-F5344CB8AC3E}">
+        <p14:creationId xmlns:p14="http://schemas.microsoft.com/office/powerpoint/2010/main" val="3648318573"/>
+      </p:ext>
+    </p:extLst>
+  </p:cSld>
+  <p:clrMapOvr>
+    <a:masterClrMapping/>
+  </p:clrMapOvr>
+</p:sld>
+</file>
+
+<file path=ppt/slides/slide21.xml><?xml version="1.0" encoding="utf-8"?>
+<p:sld xmlns:a="http://schemas.openxmlformats.org/drawingml/2006/main" xmlns:r="http://schemas.openxmlformats.org/officeDocument/2006/relationships" xmlns:p="http://schemas.openxmlformats.org/presentationml/2006/main" show="0">
+  <p:cSld>
+    <p:bg>
+      <p:bgPr>
+        <a:solidFill>
+          <a:schemeClr val="bg1"/>
+        </a:solidFill>
+        <a:effectLst/>
+      </p:bgPr>
+    </p:bg>
+    <p:spTree>
+      <p:nvGrpSpPr>
+        <p:cNvPr id="1" name=""/>
+        <p:cNvGrpSpPr/>
+        <p:nvPr/>
+      </p:nvGrpSpPr>
+      <p:grpSpPr>
+        <a:xfrm>
+          <a:off x="0" y="0"/>
+          <a:ext cx="0" cy="0"/>
+          <a:chOff x="0" y="0"/>
+          <a:chExt cx="0" cy="0"/>
+        </a:xfrm>
+      </p:grpSpPr>
+      <p:sp useBgFill="1">
+        <p:nvSpPr>
+          <p:cNvPr id="8" name="Rectangle 7">
+            <a:extLst>
+              <a:ext uri="{FF2B5EF4-FFF2-40B4-BE49-F238E27FC236}">
+                <a16:creationId xmlns:a16="http://schemas.microsoft.com/office/drawing/2014/main" id="{1B15ED52-F352-441B-82BF-E0EA34836D08}"/>
+              </a:ext>
+              <a:ext uri="{C183D7F6-B498-43B3-948B-1728B52AA6E4}">
+                <adec:decorative xmlns:adec="http://schemas.microsoft.com/office/drawing/2017/decorative" val="1"/>
+              </a:ext>
+            </a:extLst>
+          </p:cNvPr>
+          <p:cNvSpPr>
+            <a:spLocks noGrp="1" noRot="1" noChangeAspect="1" noMove="1" noResize="1" noEditPoints="1" noAdjustHandles="1" noChangeArrowheads="1" noChangeShapeType="1" noTextEdit="1"/>
+          </p:cNvSpPr>
+          <p:nvPr>
+            <p:extLst>
+              <p:ext uri="{386F3935-93C4-4BCD-93E2-E3B085C9AB24}">
+                <p16:designElem xmlns:p16="http://schemas.microsoft.com/office/powerpoint/2015/main" val="1"/>
+              </p:ext>
+            </p:extLst>
+          </p:nvPr>
+        </p:nvSpPr>
+        <p:spPr>
+          <a:xfrm>
+            <a:off x="0" y="0"/>
+            <a:ext cx="12192000" cy="6858000"/>
+          </a:xfrm>
+          <a:prstGeom prst="rect">
+            <a:avLst/>
+          </a:prstGeom>
+          <a:ln w="12700" cap="flat" cmpd="sng" algn="ctr">
+            <a:noFill/>
+            <a:prstDash val="solid"/>
+            <a:miter lim="800000"/>
+          </a:ln>
+          <a:effectLst/>
+          <a:extLst>
+            <a:ext uri="{91240B29-F687-4F45-9708-019B960494DF}">
+              <a14:hiddenLine xmlns:a14="http://schemas.microsoft.com/office/drawing/2010/main" w="12700" cap="flat" cmpd="sng" algn="ctr">
+                <a:solidFill>
+                  <a:schemeClr val="accent1">
+                    <a:shade val="50000"/>
+                  </a:schemeClr>
+                </a:solidFill>
+                <a:prstDash val="solid"/>
+                <a:miter lim="800000"/>
+              </a14:hiddenLine>
+            </a:ext>
+          </a:extLst>
+        </p:spPr>
+        <p:style>
+          <a:lnRef idx="2">
+            <a:schemeClr val="accent1">
+              <a:shade val="50000"/>
+            </a:schemeClr>
+          </a:lnRef>
+          <a:fillRef idx="1">
+            <a:schemeClr val="accent1"/>
+          </a:fillRef>
+          <a:effectRef idx="0">
+            <a:schemeClr val="accent1"/>
+          </a:effectRef>
+          <a:fontRef idx="minor">
+            <a:schemeClr val="lt1"/>
+          </a:fontRef>
+        </p:style>
+        <p:txBody>
+          <a:bodyPr rtlCol="0" anchor="ctr"/>
+          <a:lstStyle/>
+          <a:p>
+            <a:pPr algn="ctr"/>
+            <a:endParaRPr lang="en-US"/>
+          </a:p>
+        </p:txBody>
+      </p:sp>
+      <p:sp>
+        <p:nvSpPr>
           <p:cNvPr id="10" name="Rectangle 9">
             <a:extLst>
               <a:ext uri="{FF2B5EF4-FFF2-40B4-BE49-F238E27FC236}">
@@ -14480,7 +15540,7 @@
           <p:cNvPr id="2" name="Title 1">
             <a:extLst>
               <a:ext uri="{FF2B5EF4-FFF2-40B4-BE49-F238E27FC236}">
-                <a16:creationId xmlns:a16="http://schemas.microsoft.com/office/drawing/2014/main" id="{27D0DF9F-1E2D-5CFD-D2E6-89F1ED1AAC63}"/>
+                <a16:creationId xmlns:a16="http://schemas.microsoft.com/office/drawing/2014/main" id="{ED9ECE6E-66C4-96BE-76E0-E8395F0AC9DA}"/>
               </a:ext>
             </a:extLst>
           </p:cNvPr>
@@ -14509,50 +15569,47 @@
                   <a:srgbClr val="FFFFFF"/>
                 </a:solidFill>
               </a:rPr>
-              <a:t>General architecture (Testing based on)</a:t>
-            </a:r>
-          </a:p>
-        </p:txBody>
-      </p:sp>
-      <p:pic>
-        <p:nvPicPr>
-          <p:cNvPr id="5" name="Content Placeholder 4" descr="A group of white rectangular shapes with black text&#10;&#10;AI-generated content may be incorrect.">
-            <a:extLst>
-              <a:ext uri="{FF2B5EF4-FFF2-40B4-BE49-F238E27FC236}">
-                <a16:creationId xmlns:a16="http://schemas.microsoft.com/office/drawing/2014/main" id="{14E12D97-A3DA-867A-2F05-623C660A7994}"/>
-              </a:ext>
-            </a:extLst>
-          </p:cNvPr>
-          <p:cNvPicPr>
-            <a:picLocks noGrp="1" noChangeAspect="1"/>
-          </p:cNvPicPr>
+              <a:t>Overall View</a:t>
+            </a:r>
+          </a:p>
+        </p:txBody>
+      </p:sp>
+      <p:sp>
+        <p:nvSpPr>
+          <p:cNvPr id="3" name="Content Placeholder 2">
+            <a:extLst>
+              <a:ext uri="{FF2B5EF4-FFF2-40B4-BE49-F238E27FC236}">
+                <a16:creationId xmlns:a16="http://schemas.microsoft.com/office/drawing/2014/main" id="{98C9873B-F462-4550-D847-5493A0F7F3D8}"/>
+              </a:ext>
+            </a:extLst>
+          </p:cNvPr>
+          <p:cNvSpPr>
+            <a:spLocks noGrp="1"/>
+          </p:cNvSpPr>
           <p:nvPr>
             <p:ph idx="1"/>
           </p:nvPr>
-        </p:nvPicPr>
-        <p:blipFill>
-          <a:blip r:embed="rId2">
-            <a:extLst>
-              <a:ext uri="{28A0092B-C50C-407E-A947-70E740481C1C}">
-                <a14:useLocalDpi xmlns:a14="http://schemas.microsoft.com/office/drawing/2010/main" val="0"/>
-              </a:ext>
-            </a:extLst>
-          </a:blip>
-          <a:stretch>
-            <a:fillRect/>
-          </a:stretch>
-        </p:blipFill>
+        </p:nvSpPr>
         <p:spPr>
           <a:xfrm>
-            <a:off x="2209720" y="1976106"/>
-            <a:ext cx="7772560" cy="4373334"/>
+            <a:off x="1371599" y="2318197"/>
+            <a:ext cx="9724031" cy="3683358"/>
           </a:xfrm>
         </p:spPr>
-      </p:pic>
+        <p:txBody>
+          <a:bodyPr anchor="ctr">
+            <a:normAutofit/>
+          </a:bodyPr>
+          <a:lstStyle/>
+          <a:p>
+            <a:endParaRPr lang="en-US" sz="2000"/>
+          </a:p>
+        </p:txBody>
+      </p:sp>
     </p:spTree>
     <p:extLst>
       <p:ext uri="{BB962C8B-B14F-4D97-AF65-F5344CB8AC3E}">
-        <p14:creationId xmlns:p14="http://schemas.microsoft.com/office/powerpoint/2010/main" val="1308577209"/>
+        <p14:creationId xmlns:p14="http://schemas.microsoft.com/office/powerpoint/2010/main" val="1828056376"/>
       </p:ext>
     </p:extLst>
   </p:cSld>
@@ -14562,7 +15619,7 @@
 </p:sld>
 </file>
 
-<file path=ppt/slides/slide20.xml><?xml version="1.0" encoding="utf-8"?>
+<file path=ppt/slides/slide22.xml><?xml version="1.0" encoding="utf-8"?>
 <p:sld xmlns:a="http://schemas.openxmlformats.org/drawingml/2006/main" xmlns:r="http://schemas.openxmlformats.org/officeDocument/2006/relationships" xmlns:p="http://schemas.openxmlformats.org/presentationml/2006/main">
   <p:cSld>
     <p:bg>
@@ -15256,7 +16313,7 @@
 </p:sld>
 </file>
 
-<file path=ppt/slides/slide21.xml><?xml version="1.0" encoding="utf-8"?>
+<file path=ppt/slides/slide23.xml><?xml version="1.0" encoding="utf-8"?>
 <p:sld xmlns:a="http://schemas.openxmlformats.org/drawingml/2006/main" xmlns:r="http://schemas.openxmlformats.org/officeDocument/2006/relationships" xmlns:p="http://schemas.openxmlformats.org/presentationml/2006/main">
   <p:cSld>
     <p:bg>
@@ -16152,7 +17209,7 @@
 </p:sld>
 </file>
 
-<file path=ppt/slides/slide22.xml><?xml version="1.0" encoding="utf-8"?>
+<file path=ppt/slides/slide24.xml><?xml version="1.0" encoding="utf-8"?>
 <p:sld xmlns:a="http://schemas.openxmlformats.org/drawingml/2006/main" xmlns:r="http://schemas.openxmlformats.org/officeDocument/2006/relationships" xmlns:p="http://schemas.openxmlformats.org/presentationml/2006/main">
   <p:cSld>
     <p:bg>
@@ -16993,7 +18050,7 @@
 </p:sld>
 </file>
 
-<file path=ppt/slides/slide23.xml><?xml version="1.0" encoding="utf-8"?>
+<file path=ppt/slides/slide25.xml><?xml version="1.0" encoding="utf-8"?>
 <p:sld xmlns:a="http://schemas.openxmlformats.org/drawingml/2006/main" xmlns:r="http://schemas.openxmlformats.org/officeDocument/2006/relationships" xmlns:p="http://schemas.openxmlformats.org/presentationml/2006/main">
   <p:cSld>
     <p:bg>
@@ -18125,7 +19182,7 @@
 </p:sld>
 </file>
 
-<file path=ppt/slides/slide24.xml><?xml version="1.0" encoding="utf-8"?>
+<file path=ppt/slides/slide26.xml><?xml version="1.0" encoding="utf-8"?>
 <p:sld xmlns:a="http://schemas.openxmlformats.org/drawingml/2006/main" xmlns:r="http://schemas.openxmlformats.org/officeDocument/2006/relationships" xmlns:p="http://schemas.openxmlformats.org/presentationml/2006/main">
   <p:cSld>
     <p:bg>
@@ -18503,10 +19560,429 @@
       </p:sp>
       <p:pic>
         <p:nvPicPr>
+          <p:cNvPr id="4" name="Picture 3">
+            <a:extLst>
+              <a:ext uri="{FF2B5EF4-FFF2-40B4-BE49-F238E27FC236}">
+                <a16:creationId xmlns:a16="http://schemas.microsoft.com/office/drawing/2014/main" id="{E0A55FF1-FE12-1577-D322-AA1846DDA500}"/>
+              </a:ext>
+            </a:extLst>
+          </p:cNvPr>
+          <p:cNvPicPr>
+            <a:picLocks noChangeAspect="1"/>
+          </p:cNvPicPr>
+          <p:nvPr/>
+        </p:nvPicPr>
+        <p:blipFill>
+          <a:blip r:embed="rId3"/>
+          <a:stretch>
+            <a:fillRect/>
+          </a:stretch>
+        </p:blipFill>
+        <p:spPr>
+          <a:xfrm>
+            <a:off x="-3" y="1798000"/>
+            <a:ext cx="12192000" cy="4811962"/>
+          </a:xfrm>
+          <a:prstGeom prst="rect">
+            <a:avLst/>
+          </a:prstGeom>
+        </p:spPr>
+      </p:pic>
+    </p:spTree>
+    <p:extLst>
+      <p:ext uri="{BB962C8B-B14F-4D97-AF65-F5344CB8AC3E}">
+        <p14:creationId xmlns:p14="http://schemas.microsoft.com/office/powerpoint/2010/main" val="1113586432"/>
+      </p:ext>
+    </p:extLst>
+  </p:cSld>
+  <p:clrMapOvr>
+    <a:masterClrMapping/>
+  </p:clrMapOvr>
+</p:sld>
+</file>
+
+<file path=ppt/slides/slide27.xml><?xml version="1.0" encoding="utf-8"?>
+<p:sld xmlns:a="http://schemas.openxmlformats.org/drawingml/2006/main" xmlns:r="http://schemas.openxmlformats.org/officeDocument/2006/relationships" xmlns:p="http://schemas.openxmlformats.org/presentationml/2006/main" show="0">
+  <p:cSld>
+    <p:bg>
+      <p:bgPr>
+        <a:solidFill>
+          <a:schemeClr val="bg1"/>
+        </a:solidFill>
+        <a:effectLst/>
+      </p:bgPr>
+    </p:bg>
+    <p:spTree>
+      <p:nvGrpSpPr>
+        <p:cNvPr id="1" name="">
+          <a:extLst>
+            <a:ext uri="{FF2B5EF4-FFF2-40B4-BE49-F238E27FC236}">
+              <a16:creationId xmlns:a16="http://schemas.microsoft.com/office/drawing/2014/main" id="{C33EE0BA-7FF8-B6EF-D78A-F13FD8E4DD3A}"/>
+            </a:ext>
+          </a:extLst>
+        </p:cNvPr>
+        <p:cNvGrpSpPr/>
+        <p:nvPr/>
+      </p:nvGrpSpPr>
+      <p:grpSpPr>
+        <a:xfrm>
+          <a:off x="0" y="0"/>
+          <a:ext cx="0" cy="0"/>
+          <a:chOff x="0" y="0"/>
+          <a:chExt cx="0" cy="0"/>
+        </a:xfrm>
+      </p:grpSpPr>
+      <p:sp useBgFill="1">
+        <p:nvSpPr>
+          <p:cNvPr id="10" name="Rectangle 9">
+            <a:extLst>
+              <a:ext uri="{FF2B5EF4-FFF2-40B4-BE49-F238E27FC236}">
+                <a16:creationId xmlns:a16="http://schemas.microsoft.com/office/drawing/2014/main" id="{655898CF-05C8-AD7F-E018-C51903C37D4B}"/>
+              </a:ext>
+              <a:ext uri="{C183D7F6-B498-43B3-948B-1728B52AA6E4}">
+                <adec:decorative xmlns:adec="http://schemas.microsoft.com/office/drawing/2017/decorative" val="1"/>
+              </a:ext>
+            </a:extLst>
+          </p:cNvPr>
+          <p:cNvSpPr>
+            <a:spLocks noGrp="1" noRot="1" noChangeAspect="1" noMove="1" noResize="1" noEditPoints="1" noAdjustHandles="1" noChangeArrowheads="1" noChangeShapeType="1" noTextEdit="1"/>
+          </p:cNvSpPr>
+          <p:nvPr>
+            <p:extLst>
+              <p:ext uri="{386F3935-93C4-4BCD-93E2-E3B085C9AB24}">
+                <p16:designElem xmlns:p16="http://schemas.microsoft.com/office/powerpoint/2015/main" val="1"/>
+              </p:ext>
+            </p:extLst>
+          </p:nvPr>
+        </p:nvSpPr>
+        <p:spPr>
+          <a:xfrm>
+            <a:off x="0" y="0"/>
+            <a:ext cx="12192000" cy="6858000"/>
+          </a:xfrm>
+          <a:prstGeom prst="rect">
+            <a:avLst/>
+          </a:prstGeom>
+          <a:ln w="12700" cap="flat" cmpd="sng" algn="ctr">
+            <a:noFill/>
+            <a:prstDash val="solid"/>
+            <a:miter lim="800000"/>
+          </a:ln>
+          <a:effectLst/>
+          <a:extLst>
+            <a:ext uri="{91240B29-F687-4F45-9708-019B960494DF}">
+              <a14:hiddenLine xmlns:a14="http://schemas.microsoft.com/office/drawing/2010/main" w="12700" cap="flat" cmpd="sng" algn="ctr">
+                <a:solidFill>
+                  <a:schemeClr val="accent1">
+                    <a:shade val="50000"/>
+                  </a:schemeClr>
+                </a:solidFill>
+                <a:prstDash val="solid"/>
+                <a:miter lim="800000"/>
+              </a14:hiddenLine>
+            </a:ext>
+          </a:extLst>
+        </p:spPr>
+        <p:style>
+          <a:lnRef idx="2">
+            <a:schemeClr val="accent1">
+              <a:shade val="50000"/>
+            </a:schemeClr>
+          </a:lnRef>
+          <a:fillRef idx="1">
+            <a:schemeClr val="accent1"/>
+          </a:fillRef>
+          <a:effectRef idx="0">
+            <a:schemeClr val="accent1"/>
+          </a:effectRef>
+          <a:fontRef idx="minor">
+            <a:schemeClr val="lt1"/>
+          </a:fontRef>
+        </p:style>
+        <p:txBody>
+          <a:bodyPr rtlCol="0" anchor="ctr"/>
+          <a:lstStyle/>
+          <a:p>
+            <a:pPr algn="ctr"/>
+            <a:endParaRPr lang="en-US"/>
+          </a:p>
+        </p:txBody>
+      </p:sp>
+      <p:sp>
+        <p:nvSpPr>
+          <p:cNvPr id="12" name="Rectangle 11">
+            <a:extLst>
+              <a:ext uri="{FF2B5EF4-FFF2-40B4-BE49-F238E27FC236}">
+                <a16:creationId xmlns:a16="http://schemas.microsoft.com/office/drawing/2014/main" id="{BA28D157-ACBA-5B73-803B-87B156EBB3CF}"/>
+              </a:ext>
+              <a:ext uri="{C183D7F6-B498-43B3-948B-1728B52AA6E4}">
+                <adec:decorative xmlns:adec="http://schemas.microsoft.com/office/drawing/2017/decorative" val="1"/>
+              </a:ext>
+            </a:extLst>
+          </p:cNvPr>
+          <p:cNvSpPr>
+            <a:spLocks noGrp="1" noRot="1" noChangeAspect="1" noMove="1" noResize="1" noEditPoints="1" noAdjustHandles="1" noChangeArrowheads="1" noChangeShapeType="1" noTextEdit="1"/>
+          </p:cNvSpPr>
+          <p:nvPr>
+            <p:extLst>
+              <p:ext uri="{386F3935-93C4-4BCD-93E2-E3B085C9AB24}">
+                <p16:designElem xmlns:p16="http://schemas.microsoft.com/office/powerpoint/2015/main" val="1"/>
+              </p:ext>
+            </p:extLst>
+          </p:nvPr>
+        </p:nvSpPr>
+        <p:spPr>
+          <a:xfrm rot="10800000" flipH="1">
+            <a:off x="2" y="0"/>
+            <a:ext cx="12191998" cy="1575955"/>
+          </a:xfrm>
+          <a:prstGeom prst="rect">
+            <a:avLst/>
+          </a:prstGeom>
+          <a:gradFill>
+            <a:gsLst>
+              <a:gs pos="0">
+                <a:srgbClr val="000000">
+                  <a:alpha val="96000"/>
+                </a:srgbClr>
+              </a:gs>
+              <a:gs pos="100000">
+                <a:schemeClr val="accent1">
+                  <a:lumMod val="75000"/>
+                </a:schemeClr>
+              </a:gs>
+            </a:gsLst>
+            <a:lin ang="6000000" scaled="0"/>
+          </a:gradFill>
+          <a:ln>
+            <a:noFill/>
+          </a:ln>
+        </p:spPr>
+        <p:style>
+          <a:lnRef idx="2">
+            <a:schemeClr val="accent1">
+              <a:shade val="50000"/>
+            </a:schemeClr>
+          </a:lnRef>
+          <a:fillRef idx="1">
+            <a:schemeClr val="accent1"/>
+          </a:fillRef>
+          <a:effectRef idx="0">
+            <a:schemeClr val="accent1"/>
+          </a:effectRef>
+          <a:fontRef idx="minor">
+            <a:schemeClr val="lt1"/>
+          </a:fontRef>
+        </p:style>
+        <p:txBody>
+          <a:bodyPr rtlCol="0" anchor="ctr"/>
+          <a:lstStyle/>
+          <a:p>
+            <a:pPr algn="ctr"/>
+            <a:endParaRPr lang="en-US"/>
+          </a:p>
+        </p:txBody>
+      </p:sp>
+      <p:sp>
+        <p:nvSpPr>
+          <p:cNvPr id="14" name="Rectangle 13">
+            <a:extLst>
+              <a:ext uri="{FF2B5EF4-FFF2-40B4-BE49-F238E27FC236}">
+                <a16:creationId xmlns:a16="http://schemas.microsoft.com/office/drawing/2014/main" id="{E00D77B3-9BFC-8A6D-8B3B-BAFD2BF340D5}"/>
+              </a:ext>
+              <a:ext uri="{C183D7F6-B498-43B3-948B-1728B52AA6E4}">
+                <adec:decorative xmlns:adec="http://schemas.microsoft.com/office/drawing/2017/decorative" val="1"/>
+              </a:ext>
+            </a:extLst>
+          </p:cNvPr>
+          <p:cNvSpPr>
+            <a:spLocks noGrp="1" noRot="1" noChangeAspect="1" noMove="1" noResize="1" noEditPoints="1" noAdjustHandles="1" noChangeArrowheads="1" noChangeShapeType="1" noTextEdit="1"/>
+          </p:cNvSpPr>
+          <p:nvPr>
+            <p:extLst>
+              <p:ext uri="{386F3935-93C4-4BCD-93E2-E3B085C9AB24}">
+                <p16:designElem xmlns:p16="http://schemas.microsoft.com/office/powerpoint/2015/main" val="1"/>
+              </p:ext>
+            </p:extLst>
+          </p:nvPr>
+        </p:nvSpPr>
+        <p:spPr>
+          <a:xfrm>
+            <a:off x="0" y="0"/>
+            <a:ext cx="8128856" cy="1575461"/>
+          </a:xfrm>
+          <a:prstGeom prst="rect">
+            <a:avLst/>
+          </a:prstGeom>
+          <a:gradFill>
+            <a:gsLst>
+              <a:gs pos="0">
+                <a:schemeClr val="accent1">
+                  <a:alpha val="41000"/>
+                </a:schemeClr>
+              </a:gs>
+              <a:gs pos="74000">
+                <a:schemeClr val="accent1">
+                  <a:lumMod val="60000"/>
+                  <a:lumOff val="40000"/>
+                  <a:alpha val="0"/>
+                </a:schemeClr>
+              </a:gs>
+            </a:gsLst>
+            <a:lin ang="8400000" scaled="0"/>
+          </a:gradFill>
+          <a:ln>
+            <a:noFill/>
+          </a:ln>
+        </p:spPr>
+        <p:style>
+          <a:lnRef idx="2">
+            <a:schemeClr val="accent1">
+              <a:shade val="50000"/>
+            </a:schemeClr>
+          </a:lnRef>
+          <a:fillRef idx="1">
+            <a:schemeClr val="accent1"/>
+          </a:fillRef>
+          <a:effectRef idx="0">
+            <a:schemeClr val="accent1"/>
+          </a:effectRef>
+          <a:fontRef idx="minor">
+            <a:schemeClr val="lt1"/>
+          </a:fontRef>
+        </p:style>
+        <p:txBody>
+          <a:bodyPr rtlCol="0" anchor="ctr"/>
+          <a:lstStyle/>
+          <a:p>
+            <a:pPr algn="ctr"/>
+            <a:endParaRPr lang="en-US"/>
+          </a:p>
+        </p:txBody>
+      </p:sp>
+      <p:sp>
+        <p:nvSpPr>
+          <p:cNvPr id="16" name="Rectangle 15">
+            <a:extLst>
+              <a:ext uri="{FF2B5EF4-FFF2-40B4-BE49-F238E27FC236}">
+                <a16:creationId xmlns:a16="http://schemas.microsoft.com/office/drawing/2014/main" id="{526E624A-5719-652E-10C0-7E394DF18E46}"/>
+              </a:ext>
+              <a:ext uri="{C183D7F6-B498-43B3-948B-1728B52AA6E4}">
+                <adec:decorative xmlns:adec="http://schemas.microsoft.com/office/drawing/2017/decorative" val="1"/>
+              </a:ext>
+            </a:extLst>
+          </p:cNvPr>
+          <p:cNvSpPr>
+            <a:spLocks noGrp="1" noRot="1" noChangeAspect="1" noMove="1" noResize="1" noEditPoints="1" noAdjustHandles="1" noChangeArrowheads="1" noChangeShapeType="1" noTextEdit="1"/>
+          </p:cNvSpPr>
+          <p:nvPr>
+            <p:extLst>
+              <p:ext uri="{386F3935-93C4-4BCD-93E2-E3B085C9AB24}">
+                <p16:designElem xmlns:p16="http://schemas.microsoft.com/office/powerpoint/2015/main" val="1"/>
+              </p:ext>
+            </p:extLst>
+          </p:nvPr>
+        </p:nvSpPr>
+        <p:spPr>
+          <a:xfrm flipH="1">
+            <a:off x="-3" y="-1"/>
+            <a:ext cx="12192002" cy="1574311"/>
+          </a:xfrm>
+          <a:prstGeom prst="rect">
+            <a:avLst/>
+          </a:prstGeom>
+          <a:gradFill>
+            <a:gsLst>
+              <a:gs pos="0">
+                <a:srgbClr val="000000">
+                  <a:alpha val="63000"/>
+                </a:srgbClr>
+              </a:gs>
+              <a:gs pos="78000">
+                <a:schemeClr val="accent1">
+                  <a:alpha val="15000"/>
+                </a:schemeClr>
+              </a:gs>
+            </a:gsLst>
+            <a:lin ang="15600000" scaled="0"/>
+          </a:gradFill>
+          <a:ln>
+            <a:noFill/>
+          </a:ln>
+        </p:spPr>
+        <p:style>
+          <a:lnRef idx="2">
+            <a:schemeClr val="accent1">
+              <a:shade val="50000"/>
+            </a:schemeClr>
+          </a:lnRef>
+          <a:fillRef idx="1">
+            <a:schemeClr val="accent1"/>
+          </a:fillRef>
+          <a:effectRef idx="0">
+            <a:schemeClr val="accent1"/>
+          </a:effectRef>
+          <a:fontRef idx="minor">
+            <a:schemeClr val="lt1"/>
+          </a:fontRef>
+        </p:style>
+        <p:txBody>
+          <a:bodyPr rtlCol="0" anchor="ctr"/>
+          <a:lstStyle/>
+          <a:p>
+            <a:pPr algn="ctr"/>
+            <a:endParaRPr lang="en-US"/>
+          </a:p>
+        </p:txBody>
+      </p:sp>
+      <p:sp>
+        <p:nvSpPr>
+          <p:cNvPr id="2" name="Title 1">
+            <a:extLst>
+              <a:ext uri="{FF2B5EF4-FFF2-40B4-BE49-F238E27FC236}">
+                <a16:creationId xmlns:a16="http://schemas.microsoft.com/office/drawing/2014/main" id="{38F906B4-A4F6-2644-9A80-0F5B93D7B29E}"/>
+              </a:ext>
+            </a:extLst>
+          </p:cNvPr>
+          <p:cNvSpPr>
+            <a:spLocks noGrp="1"/>
+          </p:cNvSpPr>
+          <p:nvPr>
+            <p:ph type="title"/>
+          </p:nvPr>
+        </p:nvSpPr>
+        <p:spPr>
+          <a:xfrm>
+            <a:off x="699713" y="248038"/>
+            <a:ext cx="7063721" cy="1159200"/>
+          </a:xfrm>
+        </p:spPr>
+        <p:txBody>
+          <a:bodyPr vert="horz" lIns="91440" tIns="45720" rIns="91440" bIns="45720" rtlCol="0" anchor="ctr">
+            <a:normAutofit/>
+          </a:bodyPr>
+          <a:lstStyle/>
+          <a:p>
+            <a:r>
+              <a:rPr lang="en-US" sz="4000" kern="1200">
+                <a:solidFill>
+                  <a:srgbClr val="FFFFFF"/>
+                </a:solidFill>
+                <a:latin typeface="+mj-lt"/>
+                <a:ea typeface="+mj-ea"/>
+                <a:cs typeface="+mj-cs"/>
+              </a:rPr>
+              <a:t>Overall View</a:t>
+            </a:r>
+          </a:p>
+        </p:txBody>
+      </p:sp>
+      <p:pic>
+        <p:nvPicPr>
           <p:cNvPr id="5" name="Picture 4">
             <a:extLst>
               <a:ext uri="{FF2B5EF4-FFF2-40B4-BE49-F238E27FC236}">
-                <a16:creationId xmlns:a16="http://schemas.microsoft.com/office/drawing/2014/main" id="{7649AB3A-CCB3-FB7A-1699-0053D2B7A679}"/>
+                <a16:creationId xmlns:a16="http://schemas.microsoft.com/office/drawing/2014/main" id="{1A385305-1B2E-8A07-87A2-21EE2445D09D}"/>
               </a:ext>
             </a:extLst>
           </p:cNvPr>
@@ -18534,7 +20010,7 @@
     </p:spTree>
     <p:extLst>
       <p:ext uri="{BB962C8B-B14F-4D97-AF65-F5344CB8AC3E}">
-        <p14:creationId xmlns:p14="http://schemas.microsoft.com/office/powerpoint/2010/main" val="1113586432"/>
+        <p14:creationId xmlns:p14="http://schemas.microsoft.com/office/powerpoint/2010/main" val="1934449362"/>
       </p:ext>
     </p:extLst>
   </p:cSld>
@@ -18544,7 +20020,7 @@
 </p:sld>
 </file>
 
-<file path=ppt/slides/slide25.xml><?xml version="1.0" encoding="utf-8"?>
+<file path=ppt/slides/slide28.xml><?xml version="1.0" encoding="utf-8"?>
 <p:sld xmlns:a="http://schemas.openxmlformats.org/drawingml/2006/main" xmlns:r="http://schemas.openxmlformats.org/officeDocument/2006/relationships" xmlns:p="http://schemas.openxmlformats.org/presentationml/2006/main">
   <p:cSld>
     <p:bg>

</xml_diff>